<commit_message>
Q-learning slide ref #16
</commit_message>
<xml_diff>
--- a/Präsi/PP_v2.pptx
+++ b/Präsi/PP_v2.pptx
@@ -3156,7 +3156,10 @@
           <a:bodyPr/>
           <a:lstStyle/>
           <a:p>
-            <a:endParaRPr/>
+            <a:endParaRPr>
+              <a:latin typeface="Cambria" panose="02040503050406030204" pitchFamily="18" charset="0"/>
+              <a:ea typeface="Cambria" panose="02040503050406030204" pitchFamily="18" charset="0"/>
+            </a:endParaRPr>
           </a:p>
         </p:txBody>
       </p:sp>
@@ -3192,12 +3195,12 @@
               <a:buNone/>
             </a:pPr>
             <a:r>
-              <a:rPr sz="3800" b="1">
+              <a:rPr sz="3800" b="1" dirty="0">
                 <a:solidFill>
                   <a:srgbClr val="10B981"/>
                 </a:solidFill>
-                <a:latin typeface="Cambria"/>
-                <a:ea typeface="Cambria"/>
+                <a:latin typeface="Cambria" panose="02040503050406030204" pitchFamily="18" charset="0"/>
+                <a:ea typeface="Cambria" panose="02040503050406030204" pitchFamily="18" charset="0"/>
                 <a:cs typeface="Cambria"/>
               </a:rPr>
               <a:t>+1</a:t>
@@ -3237,12 +3240,24 @@
               <a:buNone/>
             </a:pPr>
             <a:r>
-              <a:rPr sz="1300" b="1">
+              <a:rPr sz="1400" b="1" dirty="0" err="1">
                 <a:solidFill>
                   <a:srgbClr val="FFFFFF"/>
                 </a:solidFill>
-              </a:rPr>
-              <a:t>Niedrige Karten</a:t>
+                <a:latin typeface="Cambria" panose="02040503050406030204" pitchFamily="18" charset="0"/>
+                <a:ea typeface="Cambria" panose="02040503050406030204" pitchFamily="18" charset="0"/>
+              </a:rPr>
+              <a:t>Niedrige</a:t>
+            </a:r>
+            <a:r>
+              <a:rPr sz="1400" b="1" dirty="0">
+                <a:solidFill>
+                  <a:srgbClr val="FFFFFF"/>
+                </a:solidFill>
+                <a:latin typeface="Cambria" panose="02040503050406030204" pitchFamily="18" charset="0"/>
+                <a:ea typeface="Cambria" panose="02040503050406030204" pitchFamily="18" charset="0"/>
+              </a:rPr>
+              <a:t> Karten</a:t>
             </a:r>
           </a:p>
         </p:txBody>
@@ -3279,13 +3294,62 @@
               <a:buNone/>
             </a:pPr>
             <a:r>
-              <a:rPr sz="950">
+              <a:rPr sz="1000" dirty="0">
                 <a:solidFill>
                   <a:srgbClr val="94A3B8"/>
                 </a:solidFill>
-              </a:rPr>
-              <a:t>2 bis 6 erhöhen den Running Count</a:t>
-            </a:r>
+                <a:latin typeface="Cambria" panose="02040503050406030204" pitchFamily="18" charset="0"/>
+                <a:ea typeface="Cambria" panose="02040503050406030204" pitchFamily="18" charset="0"/>
+              </a:rPr>
+              <a:t>2 bis 6 </a:t>
+            </a:r>
+            <a:r>
+              <a:rPr sz="1000" dirty="0" err="1">
+                <a:solidFill>
+                  <a:srgbClr val="94A3B8"/>
+                </a:solidFill>
+                <a:latin typeface="Cambria" panose="02040503050406030204" pitchFamily="18" charset="0"/>
+                <a:ea typeface="Cambria" panose="02040503050406030204" pitchFamily="18" charset="0"/>
+              </a:rPr>
+              <a:t>erhöhen</a:t>
+            </a:r>
+            <a:r>
+              <a:rPr sz="1000" dirty="0">
+                <a:solidFill>
+                  <a:srgbClr val="94A3B8"/>
+                </a:solidFill>
+                <a:latin typeface="Cambria" panose="02040503050406030204" pitchFamily="18" charset="0"/>
+                <a:ea typeface="Cambria" panose="02040503050406030204" pitchFamily="18" charset="0"/>
+              </a:rPr>
+              <a:t> den </a:t>
+            </a:r>
+            <a:r>
+              <a:rPr lang="de-DE" sz="1000" dirty="0">
+                <a:solidFill>
+                  <a:srgbClr val="94A3B8"/>
+                </a:solidFill>
+                <a:latin typeface="Cambria" panose="02040503050406030204" pitchFamily="18" charset="0"/>
+                <a:ea typeface="Cambria" panose="02040503050406030204" pitchFamily="18" charset="0"/>
+              </a:rPr>
+              <a:t>C</a:t>
+            </a:r>
+            <a:r>
+              <a:rPr sz="1000" dirty="0" err="1">
+                <a:solidFill>
+                  <a:srgbClr val="94A3B8"/>
+                </a:solidFill>
+                <a:latin typeface="Cambria" panose="02040503050406030204" pitchFamily="18" charset="0"/>
+                <a:ea typeface="Cambria" panose="02040503050406030204" pitchFamily="18" charset="0"/>
+              </a:rPr>
+              <a:t>ount</a:t>
+            </a:r>
+            <a:endParaRPr sz="1000" dirty="0">
+              <a:solidFill>
+                <a:srgbClr val="94A3B8"/>
+              </a:solidFill>
+              <a:latin typeface="Cambria" panose="02040503050406030204" pitchFamily="18" charset="0"/>
+              <a:ea typeface="Cambria" panose="02040503050406030204" pitchFamily="18" charset="0"/>
+            </a:endParaRPr>
           </a:p>
         </p:txBody>
       </p:sp>
@@ -3336,7 +3400,10 @@
           <a:bodyPr/>
           <a:lstStyle/>
           <a:p>
-            <a:endParaRPr/>
+            <a:endParaRPr>
+              <a:latin typeface="Cambria" panose="02040503050406030204" pitchFamily="18" charset="0"/>
+              <a:ea typeface="Cambria" panose="02040503050406030204" pitchFamily="18" charset="0"/>
+            </a:endParaRPr>
           </a:p>
         </p:txBody>
       </p:sp>
@@ -3376,8 +3443,8 @@
                 <a:solidFill>
                   <a:srgbClr val="64748B"/>
                 </a:solidFill>
-                <a:latin typeface="Cambria"/>
-                <a:ea typeface="Cambria"/>
+                <a:latin typeface="Cambria" panose="02040503050406030204" pitchFamily="18" charset="0"/>
+                <a:ea typeface="Cambria" panose="02040503050406030204" pitchFamily="18" charset="0"/>
                 <a:cs typeface="Cambria"/>
               </a:rPr>
               <a:t>0</a:t>
@@ -3417,10 +3484,12 @@
               <a:buNone/>
             </a:pPr>
             <a:r>
-              <a:rPr sz="1300" b="1">
+              <a:rPr sz="1400" b="1">
                 <a:solidFill>
                   <a:srgbClr val="FFFFFF"/>
                 </a:solidFill>
+                <a:latin typeface="Cambria" panose="02040503050406030204" pitchFamily="18" charset="0"/>
+                <a:ea typeface="Cambria" panose="02040503050406030204" pitchFamily="18" charset="0"/>
               </a:rPr>
               <a:t>Neutrale Karten</a:t>
             </a:r>
@@ -3459,10 +3528,12 @@
               <a:buNone/>
             </a:pPr>
             <a:r>
-              <a:rPr sz="950">
+              <a:rPr sz="1000">
                 <a:solidFill>
                   <a:srgbClr val="94A3B8"/>
                 </a:solidFill>
+                <a:latin typeface="Cambria" panose="02040503050406030204" pitchFamily="18" charset="0"/>
+                <a:ea typeface="Cambria" panose="02040503050406030204" pitchFamily="18" charset="0"/>
               </a:rPr>
               <a:t>7 bis 9 verändern den Count nicht</a:t>
             </a:r>
@@ -3505,8 +3576,8 @@
                 <a:solidFill>
                   <a:srgbClr val="1E293B"/>
                 </a:solidFill>
-                <a:latin typeface="Cambria"/>
-                <a:ea typeface="Cambria"/>
+                <a:latin typeface="Cambria" panose="02040503050406030204" pitchFamily="18" charset="0"/>
+                <a:ea typeface="Cambria" panose="02040503050406030204" pitchFamily="18" charset="0"/>
                 <a:cs typeface="Cambria"/>
               </a:rPr>
               <a:t>Vom Running zum True Count</a:t>
@@ -3561,7 +3632,10 @@
           <a:bodyPr/>
           <a:lstStyle/>
           <a:p>
-            <a:endParaRPr/>
+            <a:endParaRPr>
+              <a:latin typeface="Cambria" panose="02040503050406030204" pitchFamily="18" charset="0"/>
+              <a:ea typeface="Cambria" panose="02040503050406030204" pitchFamily="18" charset="0"/>
+            </a:endParaRPr>
           </a:p>
         </p:txBody>
       </p:sp>
@@ -3601,7 +3675,10 @@
           <a:bodyPr/>
           <a:lstStyle/>
           <a:p>
-            <a:endParaRPr/>
+            <a:endParaRPr>
+              <a:latin typeface="Cambria" panose="02040503050406030204" pitchFamily="18" charset="0"/>
+              <a:ea typeface="Cambria" panose="02040503050406030204" pitchFamily="18" charset="0"/>
+            </a:endParaRPr>
           </a:p>
         </p:txBody>
       </p:sp>
@@ -3641,6 +3718,8 @@
                 <a:solidFill>
                   <a:srgbClr val="FFFFFF"/>
                 </a:solidFill>
+                <a:latin typeface="Cambria" panose="02040503050406030204" pitchFamily="18" charset="0"/>
+                <a:ea typeface="Cambria" panose="02040503050406030204" pitchFamily="18" charset="0"/>
               </a:rPr>
               <a:t>Σ</a:t>
             </a:r>
@@ -3679,10 +3758,12 @@
               <a:buNone/>
             </a:pPr>
             <a:r>
-              <a:rPr sz="1100" b="1">
+              <a:rPr sz="1100" b="1" dirty="0">
                 <a:solidFill>
                   <a:srgbClr val="1E293B"/>
                 </a:solidFill>
+                <a:latin typeface="Cambria" panose="02040503050406030204" pitchFamily="18" charset="0"/>
+                <a:ea typeface="Cambria" panose="02040503050406030204" pitchFamily="18" charset="0"/>
               </a:rPr>
               <a:t>Running Count</a:t>
             </a:r>
@@ -3721,13 +3802,72 @@
               <a:buNone/>
             </a:pPr>
             <a:r>
-              <a:rPr sz="1000">
+              <a:rPr sz="1000" dirty="0">
                 <a:solidFill>
                   <a:srgbClr val="64748B"/>
                 </a:solidFill>
-              </a:rPr>
-              <a:t>Summe aller sichtbaren Hi-Lo-Werte</a:t>
-            </a:r>
+                <a:latin typeface="Cambria" panose="02040503050406030204" pitchFamily="18" charset="0"/>
+                <a:ea typeface="Cambria" panose="02040503050406030204" pitchFamily="18" charset="0"/>
+              </a:rPr>
+              <a:t>Summe </a:t>
+            </a:r>
+            <a:r>
+              <a:rPr sz="1000" dirty="0" err="1">
+                <a:solidFill>
+                  <a:srgbClr val="64748B"/>
+                </a:solidFill>
+                <a:latin typeface="Cambria" panose="02040503050406030204" pitchFamily="18" charset="0"/>
+                <a:ea typeface="Cambria" panose="02040503050406030204" pitchFamily="18" charset="0"/>
+              </a:rPr>
+              <a:t>aller</a:t>
+            </a:r>
+            <a:r>
+              <a:rPr sz="1000" dirty="0">
+                <a:solidFill>
+                  <a:srgbClr val="64748B"/>
+                </a:solidFill>
+                <a:latin typeface="Cambria" panose="02040503050406030204" pitchFamily="18" charset="0"/>
+                <a:ea typeface="Cambria" panose="02040503050406030204" pitchFamily="18" charset="0"/>
+              </a:rPr>
+              <a:t> </a:t>
+            </a:r>
+            <a:r>
+              <a:rPr sz="1000" dirty="0" err="1">
+                <a:solidFill>
+                  <a:srgbClr val="64748B"/>
+                </a:solidFill>
+                <a:latin typeface="Cambria" panose="02040503050406030204" pitchFamily="18" charset="0"/>
+                <a:ea typeface="Cambria" panose="02040503050406030204" pitchFamily="18" charset="0"/>
+              </a:rPr>
+              <a:t>sichtbaren</a:t>
+            </a:r>
+            <a:r>
+              <a:rPr sz="1000" dirty="0">
+                <a:solidFill>
+                  <a:srgbClr val="64748B"/>
+                </a:solidFill>
+                <a:latin typeface="Cambria" panose="02040503050406030204" pitchFamily="18" charset="0"/>
+                <a:ea typeface="Cambria" panose="02040503050406030204" pitchFamily="18" charset="0"/>
+              </a:rPr>
+              <a:t> Hi-Lo-</a:t>
+            </a:r>
+            <a:r>
+              <a:rPr sz="1000" dirty="0" err="1">
+                <a:solidFill>
+                  <a:srgbClr val="64748B"/>
+                </a:solidFill>
+                <a:latin typeface="Cambria" panose="02040503050406030204" pitchFamily="18" charset="0"/>
+                <a:ea typeface="Cambria" panose="02040503050406030204" pitchFamily="18" charset="0"/>
+              </a:rPr>
+              <a:t>Werte</a:t>
+            </a:r>
+            <a:endParaRPr sz="1000" dirty="0">
+              <a:solidFill>
+                <a:srgbClr val="64748B"/>
+              </a:solidFill>
+              <a:latin typeface="Cambria" panose="02040503050406030204" pitchFamily="18" charset="0"/>
+              <a:ea typeface="Cambria" panose="02040503050406030204" pitchFamily="18" charset="0"/>
+            </a:endParaRPr>
           </a:p>
         </p:txBody>
       </p:sp>
@@ -3778,7 +3918,10 @@
           <a:bodyPr/>
           <a:lstStyle/>
           <a:p>
-            <a:endParaRPr/>
+            <a:endParaRPr>
+              <a:latin typeface="Cambria" panose="02040503050406030204" pitchFamily="18" charset="0"/>
+              <a:ea typeface="Cambria" panose="02040503050406030204" pitchFamily="18" charset="0"/>
+            </a:endParaRPr>
           </a:p>
         </p:txBody>
       </p:sp>
@@ -3818,7 +3961,10 @@
           <a:bodyPr/>
           <a:lstStyle/>
           <a:p>
-            <a:endParaRPr/>
+            <a:endParaRPr>
+              <a:latin typeface="Cambria" panose="02040503050406030204" pitchFamily="18" charset="0"/>
+              <a:ea typeface="Cambria" panose="02040503050406030204" pitchFamily="18" charset="0"/>
+            </a:endParaRPr>
           </a:p>
         </p:txBody>
       </p:sp>
@@ -3858,6 +4004,8 @@
                 <a:solidFill>
                   <a:srgbClr val="FFFFFF"/>
                 </a:solidFill>
+                <a:latin typeface="Cambria" panose="02040503050406030204" pitchFamily="18" charset="0"/>
+                <a:ea typeface="Cambria" panose="02040503050406030204" pitchFamily="18" charset="0"/>
               </a:rPr>
               <a:t>÷</a:t>
             </a:r>
@@ -3900,6 +4048,8 @@
                 <a:solidFill>
                   <a:srgbClr val="1E293B"/>
                 </a:solidFill>
+                <a:latin typeface="Cambria" panose="02040503050406030204" pitchFamily="18" charset="0"/>
+                <a:ea typeface="Cambria" panose="02040503050406030204" pitchFamily="18" charset="0"/>
               </a:rPr>
               <a:t>Verbleibende Decks</a:t>
             </a:r>
@@ -3942,6 +4092,8 @@
                 <a:solidFill>
                   <a:srgbClr val="64748B"/>
                 </a:solidFill>
+                <a:latin typeface="Cambria" panose="02040503050406030204" pitchFamily="18" charset="0"/>
+                <a:ea typeface="Cambria" panose="02040503050406030204" pitchFamily="18" charset="0"/>
               </a:rPr>
               <a:t>verbleibende Karten / 52</a:t>
             </a:r>
@@ -3995,7 +4147,10 @@
           <a:bodyPr/>
           <a:lstStyle/>
           <a:p>
-            <a:endParaRPr/>
+            <a:endParaRPr>
+              <a:latin typeface="Cambria" panose="02040503050406030204" pitchFamily="18" charset="0"/>
+              <a:ea typeface="Cambria" panose="02040503050406030204" pitchFamily="18" charset="0"/>
+            </a:endParaRPr>
           </a:p>
         </p:txBody>
       </p:sp>
@@ -4035,7 +4190,10 @@
           <a:bodyPr/>
           <a:lstStyle/>
           <a:p>
-            <a:endParaRPr/>
+            <a:endParaRPr>
+              <a:latin typeface="Cambria" panose="02040503050406030204" pitchFamily="18" charset="0"/>
+              <a:ea typeface="Cambria" panose="02040503050406030204" pitchFamily="18" charset="0"/>
+            </a:endParaRPr>
           </a:p>
         </p:txBody>
       </p:sp>
@@ -4075,6 +4233,8 @@
                 <a:solidFill>
                   <a:srgbClr val="FFFFFF"/>
                 </a:solidFill>
+                <a:latin typeface="Cambria" panose="02040503050406030204" pitchFamily="18" charset="0"/>
+                <a:ea typeface="Cambria" panose="02040503050406030204" pitchFamily="18" charset="0"/>
               </a:rPr>
               <a:t>=</a:t>
             </a:r>
@@ -4117,6 +4277,8 @@
                 <a:solidFill>
                   <a:srgbClr val="1E293B"/>
                 </a:solidFill>
+                <a:latin typeface="Cambria" panose="02040503050406030204" pitchFamily="18" charset="0"/>
+                <a:ea typeface="Cambria" panose="02040503050406030204" pitchFamily="18" charset="0"/>
               </a:rPr>
               <a:t>True Count</a:t>
             </a:r>
@@ -4159,6 +4321,8 @@
                 <a:solidFill>
                   <a:srgbClr val="64748B"/>
                 </a:solidFill>
+                <a:latin typeface="Cambria" panose="02040503050406030204" pitchFamily="18" charset="0"/>
+                <a:ea typeface="Cambria" panose="02040503050406030204" pitchFamily="18" charset="0"/>
               </a:rPr>
               <a:t>Running Count / verbleibende Decks</a:t>
             </a:r>
@@ -4212,7 +4376,10 @@
           <a:bodyPr/>
           <a:lstStyle/>
           <a:p>
-            <a:endParaRPr/>
+            <a:endParaRPr>
+              <a:latin typeface="Cambria" panose="02040503050406030204" pitchFamily="18" charset="0"/>
+              <a:ea typeface="Cambria" panose="02040503050406030204" pitchFamily="18" charset="0"/>
+            </a:endParaRPr>
           </a:p>
         </p:txBody>
       </p:sp>
@@ -4252,8 +4419,8 @@
                 <a:solidFill>
                   <a:srgbClr val="EF4444"/>
                 </a:solidFill>
-                <a:latin typeface="Cambria"/>
-                <a:ea typeface="Cambria"/>
+                <a:latin typeface="Cambria" panose="02040503050406030204" pitchFamily="18" charset="0"/>
+                <a:ea typeface="Cambria" panose="02040503050406030204" pitchFamily="18" charset="0"/>
                 <a:cs typeface="Cambria"/>
               </a:rPr>
               <a:t>−1</a:t>
@@ -4293,10 +4460,12 @@
               <a:buNone/>
             </a:pPr>
             <a:r>
-              <a:rPr sz="1300" b="1">
+              <a:rPr sz="1400" b="1">
                 <a:solidFill>
                   <a:srgbClr val="FFFFFF"/>
                 </a:solidFill>
+                <a:latin typeface="Cambria" panose="02040503050406030204" pitchFamily="18" charset="0"/>
+                <a:ea typeface="Cambria" panose="02040503050406030204" pitchFamily="18" charset="0"/>
               </a:rPr>
               <a:t>Hohe Karten</a:t>
             </a:r>
@@ -4335,10 +4504,12 @@
               <a:buNone/>
             </a:pPr>
             <a:r>
-              <a:rPr sz="950">
+              <a:rPr sz="1000">
                 <a:solidFill>
                   <a:srgbClr val="94A3B8"/>
                 </a:solidFill>
+                <a:latin typeface="Cambria" panose="02040503050406030204" pitchFamily="18" charset="0"/>
+                <a:ea typeface="Cambria" panose="02040503050406030204" pitchFamily="18" charset="0"/>
               </a:rPr>
               <a:t>10, Bildkarten und Asse senken den Count</a:t>
             </a:r>
@@ -4729,8 +4900,8 @@
           </a:solidFill>
           <a:ln w="12700">
             <a:solidFill>
-              <a:srgbClr val="0D9488">
-                <a:alpha val="40000"/>
+              <a:srgbClr val="64748B">
+                <a:alpha val="60000"/>
               </a:srgbClr>
             </a:solidFill>
             <a:prstDash val="solid"/>
@@ -4747,10 +4918,7 @@
           <a:bodyPr/>
           <a:lstStyle/>
           <a:p>
-            <a:endParaRPr lang="de-DE">
-              <a:latin typeface="Cambria" panose="02040503050406030204" pitchFamily="18" charset="0"/>
-              <a:ea typeface="Cambria" panose="02040503050406030204" pitchFamily="18" charset="0"/>
-            </a:endParaRPr>
+            <a:endParaRPr lang="de-DE"/>
           </a:p>
         </p:txBody>
       </p:sp>
@@ -4831,8 +4999,8 @@
           </a:solidFill>
           <a:ln w="12700">
             <a:solidFill>
-              <a:srgbClr val="F59E0B">
-                <a:alpha val="40000"/>
+              <a:srgbClr val="64748B">
+                <a:alpha val="60000"/>
               </a:srgbClr>
             </a:solidFill>
             <a:prstDash val="solid"/>
@@ -4849,10 +5017,7 @@
           <a:bodyPr/>
           <a:lstStyle/>
           <a:p>
-            <a:endParaRPr lang="de-DE">
-              <a:latin typeface="Cambria" panose="02040503050406030204" pitchFamily="18" charset="0"/>
-              <a:ea typeface="Cambria" panose="02040503050406030204" pitchFamily="18" charset="0"/>
-            </a:endParaRPr>
+            <a:endParaRPr lang="de-DE"/>
           </a:p>
         </p:txBody>
       </p:sp>
@@ -6142,6 +6307,11 @@
 <file path=ppt/slides/slide13.xml><?xml version="1.0" encoding="utf-8"?>
 <p:sld xmlns:a="http://schemas.openxmlformats.org/drawingml/2006/main" xmlns:r="http://schemas.openxmlformats.org/officeDocument/2006/relationships" xmlns:p="http://schemas.openxmlformats.org/presentationml/2006/main">
   <p:cSld>
+    <p:bg>
+      <p:bgRef idx="1001">
+        <a:schemeClr val="bg1"/>
+      </p:bgRef>
+    </p:bg>
     <p:spTree>
       <p:nvGrpSpPr>
         <p:cNvPr id="1" name="">
@@ -6449,7 +6619,7 @@
     </p:extLst>
   </p:cSld>
   <p:clrMapOvr>
-    <a:masterClrMapping/>
+    <a:overrideClrMapping bg1="lt1" tx1="dk1" bg2="lt2" tx2="dk2" accent1="accent1" accent2="accent2" accent3="accent3" accent4="accent4" accent5="accent5" accent6="accent6" hlink="hlink" folHlink="folHlink"/>
   </p:clrMapOvr>
   <mc:AlternateContent xmlns:mc="http://schemas.openxmlformats.org/markup-compatibility/2006" xmlns:p14="http://schemas.microsoft.com/office/powerpoint/2010/main">
     <mc:Choice Requires="p14">
@@ -6598,9 +6768,6 @@
           <a:bodyPr wrap="square" rtlCol="0" anchor="ctr"/>
           <a:lstStyle/>
           <a:p>
-            <a:pPr marL="0" indent="0">
-              <a:buNone/>
-            </a:pPr>
             <a:r>
               <a:rPr lang="de-DE" sz="2600" b="1" dirty="0" err="1">
                 <a:solidFill>
@@ -6619,7 +6786,7 @@
                 <a:latin typeface="Cambria" panose="02040503050406030204" pitchFamily="18" charset="0"/>
                 <a:ea typeface="Cambria" panose="02040503050406030204" pitchFamily="18" charset="0"/>
               </a:rPr>
-              <a:t>: 113.760 Zustände</a:t>
+              <a:t>: 113,680 Zustände</a:t>
             </a:r>
             <a:endParaRPr lang="en-US" sz="2600" dirty="0">
               <a:solidFill>
@@ -6806,6 +6973,11 @@
 <file path=ppt/slides/slide15.xml><?xml version="1.0" encoding="utf-8"?>
 <p:sld xmlns:a="http://schemas.openxmlformats.org/drawingml/2006/main" xmlns:r="http://schemas.openxmlformats.org/officeDocument/2006/relationships" xmlns:p="http://schemas.openxmlformats.org/presentationml/2006/main">
   <p:cSld>
+    <p:bg>
+      <p:bgRef idx="1001">
+        <a:schemeClr val="bg1"/>
+      </p:bgRef>
+    </p:bg>
     <p:spTree>
       <p:nvGrpSpPr>
         <p:cNvPr id="1" name="">
@@ -7098,6 +7270,1505 @@
           </a:p>
         </p:txBody>
       </p:sp>
+      <p:sp>
+        <p:nvSpPr>
+          <p:cNvPr id="2" name="!!11">
+            <a:extLst>
+              <a:ext uri="{FF2B5EF4-FFF2-40B4-BE49-F238E27FC236}">
+                <a16:creationId xmlns:a16="http://schemas.microsoft.com/office/drawing/2014/main" id="{C9672C62-6316-9771-F1D8-F54A20BB2587}"/>
+              </a:ext>
+            </a:extLst>
+          </p:cNvPr>
+          <p:cNvSpPr/>
+          <p:nvPr/>
+        </p:nvSpPr>
+        <p:spPr>
+          <a:xfrm>
+            <a:off x="380139" y="2328543"/>
+            <a:ext cx="8383724" cy="1088951"/>
+          </a:xfrm>
+          <a:prstGeom prst="roundRect">
+            <a:avLst>
+              <a:gd name="adj" fmla="val 8750"/>
+            </a:avLst>
+          </a:prstGeom>
+          <a:solidFill>
+            <a:srgbClr val="1E293B"/>
+          </a:solidFill>
+          <a:ln w="12700">
+            <a:solidFill>
+              <a:srgbClr val="10B981">
+                <a:alpha val="60000"/>
+              </a:srgbClr>
+            </a:solidFill>
+            <a:prstDash val="solid"/>
+          </a:ln>
+          <a:effectLst>
+            <a:outerShdw blurRad="152400" dist="38100" dir="2700000" algn="bl" rotWithShape="0">
+              <a:srgbClr val="000000">
+                <a:alpha val="18000"/>
+              </a:srgbClr>
+            </a:outerShdw>
+          </a:effectLst>
+        </p:spPr>
+        <p:txBody>
+          <a:bodyPr/>
+          <a:lstStyle/>
+          <a:p>
+            <a:endParaRPr lang="de-DE">
+              <a:latin typeface="Cambria" panose="02040503050406030204" pitchFamily="18" charset="0"/>
+              <a:ea typeface="Cambria" panose="02040503050406030204" pitchFamily="18" charset="0"/>
+            </a:endParaRPr>
+          </a:p>
+        </p:txBody>
+      </p:sp>
+      <p:sp>
+        <p:nvSpPr>
+          <p:cNvPr id="6" name="Text 7">
+            <a:extLst>
+              <a:ext uri="{FF2B5EF4-FFF2-40B4-BE49-F238E27FC236}">
+                <a16:creationId xmlns:a16="http://schemas.microsoft.com/office/drawing/2014/main" id="{B021D101-425F-90D8-52EC-03049EEB7A4E}"/>
+              </a:ext>
+            </a:extLst>
+          </p:cNvPr>
+          <p:cNvSpPr/>
+          <p:nvPr/>
+        </p:nvSpPr>
+        <p:spPr>
+          <a:xfrm>
+            <a:off x="380139" y="2444615"/>
+            <a:ext cx="8383724" cy="386847"/>
+          </a:xfrm>
+          <a:prstGeom prst="rect">
+            <a:avLst/>
+          </a:prstGeom>
+          <a:noFill/>
+          <a:ln/>
+        </p:spPr>
+        <p:txBody>
+          <a:bodyPr wrap="square" lIns="0" tIns="0" rIns="0" bIns="0" rtlCol="0" anchor="ctr"/>
+          <a:lstStyle/>
+          <a:p>
+            <a:pPr algn="ctr"/>
+            <a:r>
+              <a:rPr lang="en-US" sz="2000" b="1" dirty="0">
+                <a:solidFill>
+                  <a:srgbClr val="14B8A6"/>
+                </a:solidFill>
+                <a:latin typeface="Cambria" panose="02040503050406030204" pitchFamily="18" charset="0"/>
+                <a:ea typeface="Cambria" panose="02040503050406030204" pitchFamily="18" charset="0"/>
+              </a:rPr>
+              <a:t>Bellman Update-</a:t>
+            </a:r>
+            <a:r>
+              <a:rPr lang="en-US" sz="2000" b="1" dirty="0" err="1">
+                <a:solidFill>
+                  <a:srgbClr val="14B8A6"/>
+                </a:solidFill>
+                <a:latin typeface="Cambria" panose="02040503050406030204" pitchFamily="18" charset="0"/>
+                <a:ea typeface="Cambria" panose="02040503050406030204" pitchFamily="18" charset="0"/>
+              </a:rPr>
+              <a:t>Gleichung</a:t>
+            </a:r>
+            <a:endParaRPr lang="en-US" sz="2000" b="1" dirty="0">
+              <a:solidFill>
+                <a:srgbClr val="14B8A6"/>
+              </a:solidFill>
+              <a:latin typeface="Cambria" panose="02040503050406030204" pitchFamily="18" charset="0"/>
+              <a:ea typeface="Cambria" panose="02040503050406030204" pitchFamily="18" charset="0"/>
+            </a:endParaRPr>
+          </a:p>
+        </p:txBody>
+      </p:sp>
+      <p:sp>
+        <p:nvSpPr>
+          <p:cNvPr id="7" name="Text 8">
+            <a:extLst>
+              <a:ext uri="{FF2B5EF4-FFF2-40B4-BE49-F238E27FC236}">
+                <a16:creationId xmlns:a16="http://schemas.microsoft.com/office/drawing/2014/main" id="{9DBD9949-C6D0-ECD6-AE10-C7EF96539D04}"/>
+              </a:ext>
+            </a:extLst>
+          </p:cNvPr>
+          <p:cNvSpPr/>
+          <p:nvPr/>
+        </p:nvSpPr>
+        <p:spPr>
+          <a:xfrm>
+            <a:off x="380139" y="2801894"/>
+            <a:ext cx="8383724" cy="615600"/>
+          </a:xfrm>
+          <a:prstGeom prst="rect">
+            <a:avLst/>
+          </a:prstGeom>
+          <a:noFill/>
+          <a:ln/>
+        </p:spPr>
+        <p:txBody>
+          <a:bodyPr wrap="square" lIns="0" tIns="0" rIns="0" bIns="0" rtlCol="0" anchor="ctr"/>
+          <a:lstStyle/>
+          <a:p>
+            <a:pPr marL="0" indent="0" algn="ctr">
+              <a:buNone/>
+            </a:pPr>
+            <a:r>
+              <a:rPr lang="en-US" sz="1400" b="1" spc="200" dirty="0">
+                <a:solidFill>
+                  <a:srgbClr val="FFFFFF"/>
+                </a:solidFill>
+                <a:latin typeface="Cambria" panose="02040503050406030204" pitchFamily="18" charset="0"/>
+                <a:ea typeface="Cambria" panose="02040503050406030204" pitchFamily="18" charset="0"/>
+                <a:cs typeface="Courier New" pitchFamily="34" charset="-120"/>
+              </a:rPr>
+              <a:t>Q(</a:t>
+            </a:r>
+            <a:r>
+              <a:rPr lang="en-US" sz="1400" b="1" spc="200" dirty="0" err="1">
+                <a:solidFill>
+                  <a:srgbClr val="FFFFFF"/>
+                </a:solidFill>
+                <a:latin typeface="Cambria" panose="02040503050406030204" pitchFamily="18" charset="0"/>
+                <a:ea typeface="Cambria" panose="02040503050406030204" pitchFamily="18" charset="0"/>
+                <a:cs typeface="Courier New" pitchFamily="34" charset="-120"/>
+              </a:rPr>
+              <a:t>s,a</a:t>
+            </a:r>
+            <a:r>
+              <a:rPr lang="en-US" sz="1400" b="1" spc="200" dirty="0">
+                <a:solidFill>
+                  <a:srgbClr val="FFFFFF"/>
+                </a:solidFill>
+                <a:latin typeface="Cambria" panose="02040503050406030204" pitchFamily="18" charset="0"/>
+                <a:ea typeface="Cambria" panose="02040503050406030204" pitchFamily="18" charset="0"/>
+                <a:cs typeface="Courier New" pitchFamily="34" charset="-120"/>
+              </a:rPr>
+              <a:t>) ← Q(</a:t>
+            </a:r>
+            <a:r>
+              <a:rPr lang="en-US" sz="1400" b="1" spc="200" dirty="0" err="1">
+                <a:solidFill>
+                  <a:srgbClr val="FFFFFF"/>
+                </a:solidFill>
+                <a:latin typeface="Cambria" panose="02040503050406030204" pitchFamily="18" charset="0"/>
+                <a:ea typeface="Cambria" panose="02040503050406030204" pitchFamily="18" charset="0"/>
+                <a:cs typeface="Courier New" pitchFamily="34" charset="-120"/>
+              </a:rPr>
+              <a:t>s,a</a:t>
+            </a:r>
+            <a:r>
+              <a:rPr lang="en-US" sz="1400" b="1" spc="200" dirty="0">
+                <a:solidFill>
+                  <a:srgbClr val="FFFFFF"/>
+                </a:solidFill>
+                <a:latin typeface="Cambria" panose="02040503050406030204" pitchFamily="18" charset="0"/>
+                <a:ea typeface="Cambria" panose="02040503050406030204" pitchFamily="18" charset="0"/>
+                <a:cs typeface="Courier New" pitchFamily="34" charset="-120"/>
+              </a:rPr>
+              <a:t>) + α · [ r + γ · max Q(</a:t>
+            </a:r>
+            <a:r>
+              <a:rPr lang="en-US" sz="1400" b="1" spc="200" dirty="0" err="1">
+                <a:solidFill>
+                  <a:srgbClr val="FFFFFF"/>
+                </a:solidFill>
+                <a:latin typeface="Cambria" panose="02040503050406030204" pitchFamily="18" charset="0"/>
+                <a:ea typeface="Cambria" panose="02040503050406030204" pitchFamily="18" charset="0"/>
+                <a:cs typeface="Courier New" pitchFamily="34" charset="-120"/>
+              </a:rPr>
+              <a:t>s',a</a:t>
+            </a:r>
+            <a:r>
+              <a:rPr lang="en-US" sz="1400" b="1" spc="200" dirty="0">
+                <a:solidFill>
+                  <a:srgbClr val="FFFFFF"/>
+                </a:solidFill>
+                <a:latin typeface="Cambria" panose="02040503050406030204" pitchFamily="18" charset="0"/>
+                <a:ea typeface="Cambria" panose="02040503050406030204" pitchFamily="18" charset="0"/>
+                <a:cs typeface="Courier New" pitchFamily="34" charset="-120"/>
+              </a:rPr>
+              <a:t>') − Q(</a:t>
+            </a:r>
+            <a:r>
+              <a:rPr lang="en-US" sz="1400" b="1" spc="200" dirty="0" err="1">
+                <a:solidFill>
+                  <a:srgbClr val="FFFFFF"/>
+                </a:solidFill>
+                <a:latin typeface="Cambria" panose="02040503050406030204" pitchFamily="18" charset="0"/>
+                <a:ea typeface="Cambria" panose="02040503050406030204" pitchFamily="18" charset="0"/>
+                <a:cs typeface="Courier New" pitchFamily="34" charset="-120"/>
+              </a:rPr>
+              <a:t>s,a</a:t>
+            </a:r>
+            <a:r>
+              <a:rPr lang="en-US" sz="1400" b="1" spc="200" dirty="0">
+                <a:solidFill>
+                  <a:srgbClr val="FFFFFF"/>
+                </a:solidFill>
+                <a:latin typeface="Cambria" panose="02040503050406030204" pitchFamily="18" charset="0"/>
+                <a:ea typeface="Cambria" panose="02040503050406030204" pitchFamily="18" charset="0"/>
+                <a:cs typeface="Courier New" pitchFamily="34" charset="-120"/>
+              </a:rPr>
+              <a:t>) ]</a:t>
+            </a:r>
+            <a:endParaRPr lang="en-US" sz="1400" spc="200" dirty="0">
+              <a:latin typeface="Cambria" panose="02040503050406030204" pitchFamily="18" charset="0"/>
+              <a:ea typeface="Cambria" panose="02040503050406030204" pitchFamily="18" charset="0"/>
+            </a:endParaRPr>
+          </a:p>
+        </p:txBody>
+      </p:sp>
+      <p:sp>
+        <p:nvSpPr>
+          <p:cNvPr id="14" name="!!11">
+            <a:extLst>
+              <a:ext uri="{FF2B5EF4-FFF2-40B4-BE49-F238E27FC236}">
+                <a16:creationId xmlns:a16="http://schemas.microsoft.com/office/drawing/2014/main" id="{76C1680F-89A5-C71F-FFA4-EEA1548D80EA}"/>
+              </a:ext>
+            </a:extLst>
+          </p:cNvPr>
+          <p:cNvSpPr/>
+          <p:nvPr/>
+        </p:nvSpPr>
+        <p:spPr>
+          <a:xfrm>
+            <a:off x="380138" y="3652432"/>
+            <a:ext cx="1735979" cy="1216748"/>
+          </a:xfrm>
+          <a:prstGeom prst="roundRect">
+            <a:avLst>
+              <a:gd name="adj" fmla="val 8750"/>
+            </a:avLst>
+          </a:prstGeom>
+          <a:solidFill>
+            <a:srgbClr val="F1F5F9"/>
+          </a:solidFill>
+          <a:ln w="12700">
+            <a:solidFill>
+              <a:srgbClr val="0D9488">
+                <a:alpha val="40000"/>
+              </a:srgbClr>
+            </a:solidFill>
+            <a:prstDash val="solid"/>
+          </a:ln>
+          <a:effectLst>
+            <a:outerShdw blurRad="101600" dist="25400" dir="2700000" algn="bl" rotWithShape="0">
+              <a:srgbClr val="000000">
+                <a:alpha val="14000"/>
+              </a:srgbClr>
+            </a:outerShdw>
+          </a:effectLst>
+        </p:spPr>
+        <p:txBody>
+          <a:bodyPr/>
+          <a:lstStyle/>
+          <a:p>
+            <a:endParaRPr lang="de-DE">
+              <a:latin typeface="Cambria" panose="02040503050406030204" pitchFamily="18" charset="0"/>
+              <a:ea typeface="Cambria" panose="02040503050406030204" pitchFamily="18" charset="0"/>
+            </a:endParaRPr>
+          </a:p>
+        </p:txBody>
+      </p:sp>
+      <p:sp>
+        <p:nvSpPr>
+          <p:cNvPr id="20" name="Text 10">
+            <a:extLst>
+              <a:ext uri="{FF2B5EF4-FFF2-40B4-BE49-F238E27FC236}">
+                <a16:creationId xmlns:a16="http://schemas.microsoft.com/office/drawing/2014/main" id="{5F80E762-E91E-94E4-0650-D2E26A49C89B}"/>
+              </a:ext>
+            </a:extLst>
+          </p:cNvPr>
+          <p:cNvSpPr/>
+          <p:nvPr/>
+        </p:nvSpPr>
+        <p:spPr>
+          <a:xfrm>
+            <a:off x="380138" y="3722719"/>
+            <a:ext cx="1735979" cy="342210"/>
+          </a:xfrm>
+          <a:prstGeom prst="rect">
+            <a:avLst/>
+          </a:prstGeom>
+          <a:noFill/>
+          <a:ln/>
+        </p:spPr>
+        <p:txBody>
+          <a:bodyPr wrap="square" lIns="0" tIns="0" rIns="0" bIns="0" rtlCol="0" anchor="ctr"/>
+          <a:lstStyle/>
+          <a:p>
+            <a:pPr marL="0" indent="0" algn="ctr">
+              <a:buNone/>
+            </a:pPr>
+            <a:r>
+              <a:rPr lang="en-US" sz="2400" b="1" dirty="0">
+                <a:solidFill>
+                  <a:srgbClr val="14B8A6"/>
+                </a:solidFill>
+                <a:latin typeface="Cambria" panose="02040503050406030204" pitchFamily="18" charset="0"/>
+                <a:ea typeface="Cambria" panose="02040503050406030204" pitchFamily="18" charset="0"/>
+                <a:cs typeface="Cambria" pitchFamily="34" charset="-120"/>
+              </a:rPr>
+              <a:t>α</a:t>
+            </a:r>
+            <a:endParaRPr lang="en-US" sz="2400" dirty="0">
+              <a:latin typeface="Cambria" panose="02040503050406030204" pitchFamily="18" charset="0"/>
+              <a:ea typeface="Cambria" panose="02040503050406030204" pitchFamily="18" charset="0"/>
+            </a:endParaRPr>
+          </a:p>
+        </p:txBody>
+      </p:sp>
+      <p:sp>
+        <p:nvSpPr>
+          <p:cNvPr id="21" name="Text 11">
+            <a:extLst>
+              <a:ext uri="{FF2B5EF4-FFF2-40B4-BE49-F238E27FC236}">
+                <a16:creationId xmlns:a16="http://schemas.microsoft.com/office/drawing/2014/main" id="{C06C0C33-C44A-8094-5DCE-B3AD9E7A12E5}"/>
+              </a:ext>
+            </a:extLst>
+          </p:cNvPr>
+          <p:cNvSpPr/>
+          <p:nvPr/>
+        </p:nvSpPr>
+        <p:spPr>
+          <a:xfrm>
+            <a:off x="380138" y="4071612"/>
+            <a:ext cx="1735979" cy="228140"/>
+          </a:xfrm>
+          <a:prstGeom prst="rect">
+            <a:avLst/>
+          </a:prstGeom>
+          <a:noFill/>
+          <a:ln/>
+        </p:spPr>
+        <p:txBody>
+          <a:bodyPr wrap="square" lIns="0" tIns="0" rIns="0" bIns="0" rtlCol="0" anchor="ctr"/>
+          <a:lstStyle/>
+          <a:p>
+            <a:pPr marL="0" indent="0" algn="ctr">
+              <a:buNone/>
+            </a:pPr>
+            <a:r>
+              <a:rPr lang="en-US" sz="1200" b="1">
+                <a:solidFill>
+                  <a:srgbClr val="F59E0B"/>
+                </a:solidFill>
+                <a:latin typeface="Cambria" panose="02040503050406030204" pitchFamily="18" charset="0"/>
+                <a:ea typeface="Cambria" panose="02040503050406030204" pitchFamily="18" charset="0"/>
+              </a:rPr>
+              <a:t>0.01</a:t>
+            </a:r>
+            <a:endParaRPr lang="en-US" sz="1200" dirty="0">
+              <a:latin typeface="Cambria" panose="02040503050406030204" pitchFamily="18" charset="0"/>
+              <a:ea typeface="Cambria" panose="02040503050406030204" pitchFamily="18" charset="0"/>
+            </a:endParaRPr>
+          </a:p>
+        </p:txBody>
+      </p:sp>
+      <p:sp>
+        <p:nvSpPr>
+          <p:cNvPr id="22" name="Text 12">
+            <a:extLst>
+              <a:ext uri="{FF2B5EF4-FFF2-40B4-BE49-F238E27FC236}">
+                <a16:creationId xmlns:a16="http://schemas.microsoft.com/office/drawing/2014/main" id="{B05AF582-F406-C2FA-04AA-ADA3410564B3}"/>
+              </a:ext>
+            </a:extLst>
+          </p:cNvPr>
+          <p:cNvSpPr/>
+          <p:nvPr/>
+        </p:nvSpPr>
+        <p:spPr>
+          <a:xfrm>
+            <a:off x="380138" y="4322566"/>
+            <a:ext cx="1735979" cy="167303"/>
+          </a:xfrm>
+          <a:prstGeom prst="rect">
+            <a:avLst/>
+          </a:prstGeom>
+          <a:noFill/>
+        </p:spPr>
+        <p:txBody>
+          <a:bodyPr wrap="square" lIns="0" tIns="0" rIns="0" bIns="0" anchor="ctr"/>
+          <a:lstStyle/>
+          <a:p>
+            <a:pPr algn="ctr"/>
+            <a:r>
+              <a:rPr lang="en-US" sz="1100" b="1" dirty="0">
+                <a:solidFill>
+                  <a:srgbClr val="1E293B"/>
+                </a:solidFill>
+                <a:latin typeface="Cambria" panose="02040503050406030204" pitchFamily="18" charset="0"/>
+                <a:ea typeface="Cambria" panose="02040503050406030204" pitchFamily="18" charset="0"/>
+              </a:rPr>
+              <a:t>Learning Rate</a:t>
+            </a:r>
+          </a:p>
+        </p:txBody>
+      </p:sp>
+      <p:sp>
+        <p:nvSpPr>
+          <p:cNvPr id="23" name="Text 13">
+            <a:extLst>
+              <a:ext uri="{FF2B5EF4-FFF2-40B4-BE49-F238E27FC236}">
+                <a16:creationId xmlns:a16="http://schemas.microsoft.com/office/drawing/2014/main" id="{8FA16E2E-5CDB-04EE-9482-6803F9287DEC}"/>
+              </a:ext>
+            </a:extLst>
+          </p:cNvPr>
+          <p:cNvSpPr/>
+          <p:nvPr/>
+        </p:nvSpPr>
+        <p:spPr>
+          <a:xfrm>
+            <a:off x="380138" y="4519365"/>
+            <a:ext cx="1735979" cy="197722"/>
+          </a:xfrm>
+          <a:prstGeom prst="rect">
+            <a:avLst/>
+          </a:prstGeom>
+          <a:noFill/>
+          <a:ln/>
+        </p:spPr>
+        <p:txBody>
+          <a:bodyPr wrap="square" lIns="0" tIns="0" rIns="0" bIns="0" rtlCol="0" anchor="ctr"/>
+          <a:lstStyle/>
+          <a:p>
+            <a:pPr marL="0" indent="0" algn="ctr">
+              <a:buNone/>
+            </a:pPr>
+            <a:r>
+              <a:rPr lang="en-US" sz="850" dirty="0" err="1">
+                <a:solidFill>
+                  <a:srgbClr val="94A3B8"/>
+                </a:solidFill>
+                <a:latin typeface="Cambria" panose="02040503050406030204" pitchFamily="18" charset="0"/>
+                <a:ea typeface="Cambria" panose="02040503050406030204" pitchFamily="18" charset="0"/>
+              </a:rPr>
+              <a:t>Schrittweite</a:t>
+            </a:r>
+            <a:r>
+              <a:rPr lang="en-US" sz="850" dirty="0">
+                <a:solidFill>
+                  <a:srgbClr val="94A3B8"/>
+                </a:solidFill>
+                <a:latin typeface="Cambria" panose="02040503050406030204" pitchFamily="18" charset="0"/>
+                <a:ea typeface="Cambria" panose="02040503050406030204" pitchFamily="18" charset="0"/>
+              </a:rPr>
+              <a:t> der Updates</a:t>
+            </a:r>
+            <a:endParaRPr lang="en-US" sz="850" dirty="0">
+              <a:latin typeface="Cambria" panose="02040503050406030204" pitchFamily="18" charset="0"/>
+              <a:ea typeface="Cambria" panose="02040503050406030204" pitchFamily="18" charset="0"/>
+            </a:endParaRPr>
+          </a:p>
+        </p:txBody>
+      </p:sp>
+      <p:sp>
+        <p:nvSpPr>
+          <p:cNvPr id="8" name="!!11">
+            <a:extLst>
+              <a:ext uri="{FF2B5EF4-FFF2-40B4-BE49-F238E27FC236}">
+                <a16:creationId xmlns:a16="http://schemas.microsoft.com/office/drawing/2014/main" id="{F1803012-E686-F49B-E45F-856B7EEE151B}"/>
+              </a:ext>
+            </a:extLst>
+          </p:cNvPr>
+          <p:cNvSpPr/>
+          <p:nvPr/>
+        </p:nvSpPr>
+        <p:spPr>
+          <a:xfrm>
+            <a:off x="4217389" y="3652432"/>
+            <a:ext cx="4542838" cy="1216748"/>
+          </a:xfrm>
+          <a:prstGeom prst="roundRect">
+            <a:avLst>
+              <a:gd name="adj" fmla="val 8750"/>
+            </a:avLst>
+          </a:prstGeom>
+          <a:solidFill>
+            <a:srgbClr val="F1F5F9"/>
+          </a:solidFill>
+          <a:ln w="12700">
+            <a:solidFill>
+              <a:srgbClr val="0D9488">
+                <a:alpha val="40000"/>
+              </a:srgbClr>
+            </a:solidFill>
+            <a:prstDash val="solid"/>
+          </a:ln>
+          <a:effectLst>
+            <a:outerShdw blurRad="101600" dist="25400" dir="2700000" algn="bl" rotWithShape="0">
+              <a:srgbClr val="000000">
+                <a:alpha val="14000"/>
+              </a:srgbClr>
+            </a:outerShdw>
+          </a:effectLst>
+        </p:spPr>
+        <p:txBody>
+          <a:bodyPr/>
+          <a:lstStyle/>
+          <a:p>
+            <a:endParaRPr lang="de-DE" dirty="0">
+              <a:latin typeface="Cambria" panose="02040503050406030204" pitchFamily="18" charset="0"/>
+              <a:ea typeface="Cambria" panose="02040503050406030204" pitchFamily="18" charset="0"/>
+            </a:endParaRPr>
+          </a:p>
+        </p:txBody>
+      </p:sp>
+      <p:sp>
+        <p:nvSpPr>
+          <p:cNvPr id="24" name="Text 15">
+            <a:extLst>
+              <a:ext uri="{FF2B5EF4-FFF2-40B4-BE49-F238E27FC236}">
+                <a16:creationId xmlns:a16="http://schemas.microsoft.com/office/drawing/2014/main" id="{489C219A-95C9-CE10-66A5-A0099FC5B31C}"/>
+              </a:ext>
+            </a:extLst>
+          </p:cNvPr>
+          <p:cNvSpPr/>
+          <p:nvPr/>
+        </p:nvSpPr>
+        <p:spPr>
+          <a:xfrm>
+            <a:off x="4217390" y="3717092"/>
+            <a:ext cx="4603344" cy="342210"/>
+          </a:xfrm>
+          <a:prstGeom prst="rect">
+            <a:avLst/>
+          </a:prstGeom>
+          <a:noFill/>
+          <a:ln/>
+        </p:spPr>
+        <p:txBody>
+          <a:bodyPr wrap="square" lIns="0" tIns="0" rIns="0" bIns="0" rtlCol="0" anchor="ctr"/>
+          <a:lstStyle/>
+          <a:p>
+            <a:pPr marL="0" indent="0" algn="ctr">
+              <a:buNone/>
+            </a:pPr>
+            <a:r>
+              <a:rPr lang="el-GR" sz="2400" b="1" dirty="0">
+                <a:solidFill>
+                  <a:srgbClr val="14B8A6"/>
+                </a:solidFill>
+                <a:latin typeface="Cambria" panose="02040503050406030204" pitchFamily="18" charset="0"/>
+                <a:ea typeface="Cambria" panose="02040503050406030204" pitchFamily="18" charset="0"/>
+                <a:cs typeface="Cambria" pitchFamily="34" charset="-120"/>
+              </a:rPr>
+              <a:t>ε</a:t>
+            </a:r>
+          </a:p>
+        </p:txBody>
+      </p:sp>
+      <p:sp>
+        <p:nvSpPr>
+          <p:cNvPr id="25" name="Text 16">
+            <a:extLst>
+              <a:ext uri="{FF2B5EF4-FFF2-40B4-BE49-F238E27FC236}">
+                <a16:creationId xmlns:a16="http://schemas.microsoft.com/office/drawing/2014/main" id="{2B2AAC53-0EF0-6A0E-E1F8-06F7F18DA57C}"/>
+              </a:ext>
+            </a:extLst>
+          </p:cNvPr>
+          <p:cNvSpPr/>
+          <p:nvPr/>
+        </p:nvSpPr>
+        <p:spPr>
+          <a:xfrm>
+            <a:off x="5749378" y="4071612"/>
+            <a:ext cx="1539367" cy="228140"/>
+          </a:xfrm>
+          <a:prstGeom prst="rect">
+            <a:avLst/>
+          </a:prstGeom>
+          <a:noFill/>
+          <a:ln/>
+        </p:spPr>
+        <p:txBody>
+          <a:bodyPr wrap="square" lIns="0" tIns="0" rIns="0" bIns="0" rtlCol="0" anchor="ctr"/>
+          <a:lstStyle/>
+          <a:p>
+            <a:pPr marL="0" indent="0" algn="ctr">
+              <a:buNone/>
+            </a:pPr>
+            <a:r>
+              <a:rPr lang="en-US" sz="1200" b="1" dirty="0">
+                <a:solidFill>
+                  <a:srgbClr val="F59E0B"/>
+                </a:solidFill>
+                <a:latin typeface="Cambria" panose="02040503050406030204" pitchFamily="18" charset="0"/>
+                <a:ea typeface="Cambria" panose="02040503050406030204" pitchFamily="18" charset="0"/>
+              </a:rPr>
+              <a:t>0.90</a:t>
+            </a:r>
+          </a:p>
+        </p:txBody>
+      </p:sp>
+      <p:sp>
+        <p:nvSpPr>
+          <p:cNvPr id="26" name="Text 17">
+            <a:extLst>
+              <a:ext uri="{FF2B5EF4-FFF2-40B4-BE49-F238E27FC236}">
+                <a16:creationId xmlns:a16="http://schemas.microsoft.com/office/drawing/2014/main" id="{7F588953-04E4-30AA-7CFC-DA26AEA2F7ED}"/>
+              </a:ext>
+            </a:extLst>
+          </p:cNvPr>
+          <p:cNvSpPr/>
+          <p:nvPr/>
+        </p:nvSpPr>
+        <p:spPr>
+          <a:xfrm>
+            <a:off x="5749378" y="4322566"/>
+            <a:ext cx="1539367" cy="167303"/>
+          </a:xfrm>
+          <a:prstGeom prst="rect">
+            <a:avLst/>
+          </a:prstGeom>
+          <a:noFill/>
+        </p:spPr>
+        <p:txBody>
+          <a:bodyPr wrap="square" lIns="0" tIns="0" rIns="0" bIns="0" anchor="ctr"/>
+          <a:lstStyle/>
+          <a:p>
+            <a:pPr algn="ctr"/>
+            <a:r>
+              <a:rPr lang="en-US" sz="1100" b="1" dirty="0">
+                <a:solidFill>
+                  <a:srgbClr val="1E293B"/>
+                </a:solidFill>
+                <a:latin typeface="Cambria" panose="02040503050406030204" pitchFamily="18" charset="0"/>
+                <a:ea typeface="Cambria" panose="02040503050406030204" pitchFamily="18" charset="0"/>
+              </a:rPr>
+              <a:t>Decay</a:t>
+            </a:r>
+          </a:p>
+        </p:txBody>
+      </p:sp>
+      <p:sp>
+        <p:nvSpPr>
+          <p:cNvPr id="27" name="Text 18">
+            <a:extLst>
+              <a:ext uri="{FF2B5EF4-FFF2-40B4-BE49-F238E27FC236}">
+                <a16:creationId xmlns:a16="http://schemas.microsoft.com/office/drawing/2014/main" id="{8854A8C1-7E4E-59CB-E51D-F7FD449B9D3A}"/>
+              </a:ext>
+            </a:extLst>
+          </p:cNvPr>
+          <p:cNvSpPr/>
+          <p:nvPr/>
+        </p:nvSpPr>
+        <p:spPr>
+          <a:xfrm>
+            <a:off x="5749378" y="4519365"/>
+            <a:ext cx="1539367" cy="197722"/>
+          </a:xfrm>
+          <a:prstGeom prst="rect">
+            <a:avLst/>
+          </a:prstGeom>
+          <a:noFill/>
+          <a:ln/>
+        </p:spPr>
+        <p:txBody>
+          <a:bodyPr wrap="square" lIns="0" tIns="0" rIns="0" bIns="0" rtlCol="0" anchor="ctr"/>
+          <a:lstStyle/>
+          <a:p>
+            <a:pPr marL="0" indent="0" algn="ctr">
+              <a:buNone/>
+            </a:pPr>
+            <a:r>
+              <a:rPr lang="en-US" sz="850" dirty="0" err="1">
+                <a:solidFill>
+                  <a:srgbClr val="94A3B8"/>
+                </a:solidFill>
+                <a:latin typeface="Cambria" panose="02040503050406030204" pitchFamily="18" charset="0"/>
+                <a:ea typeface="Cambria" panose="02040503050406030204" pitchFamily="18" charset="0"/>
+              </a:rPr>
+              <a:t>Langsame</a:t>
+            </a:r>
+            <a:r>
+              <a:rPr lang="en-US" sz="850" dirty="0">
+                <a:solidFill>
+                  <a:srgbClr val="94A3B8"/>
+                </a:solidFill>
+                <a:latin typeface="Cambria" panose="02040503050406030204" pitchFamily="18" charset="0"/>
+                <a:ea typeface="Cambria" panose="02040503050406030204" pitchFamily="18" charset="0"/>
+              </a:rPr>
+              <a:t>, </a:t>
+            </a:r>
+            <a:r>
+              <a:rPr lang="en-US" sz="850" dirty="0" err="1">
+                <a:solidFill>
+                  <a:srgbClr val="94A3B8"/>
+                </a:solidFill>
+                <a:latin typeface="Cambria" panose="02040503050406030204" pitchFamily="18" charset="0"/>
+                <a:ea typeface="Cambria" panose="02040503050406030204" pitchFamily="18" charset="0"/>
+              </a:rPr>
+              <a:t>schrittweise</a:t>
+            </a:r>
+            <a:r>
+              <a:rPr lang="en-US" sz="850" dirty="0">
+                <a:solidFill>
+                  <a:srgbClr val="94A3B8"/>
+                </a:solidFill>
+                <a:latin typeface="Cambria" panose="02040503050406030204" pitchFamily="18" charset="0"/>
+                <a:ea typeface="Cambria" panose="02040503050406030204" pitchFamily="18" charset="0"/>
+              </a:rPr>
+              <a:t> </a:t>
+            </a:r>
+            <a:r>
+              <a:rPr lang="en-US" sz="850" dirty="0" err="1">
+                <a:solidFill>
+                  <a:srgbClr val="94A3B8"/>
+                </a:solidFill>
+                <a:latin typeface="Cambria" panose="02040503050406030204" pitchFamily="18" charset="0"/>
+                <a:ea typeface="Cambria" panose="02040503050406030204" pitchFamily="18" charset="0"/>
+              </a:rPr>
+              <a:t>Reduktion</a:t>
+            </a:r>
+            <a:endParaRPr lang="en-US" sz="850" dirty="0">
+              <a:solidFill>
+                <a:srgbClr val="94A3B8"/>
+              </a:solidFill>
+              <a:latin typeface="Cambria" panose="02040503050406030204" pitchFamily="18" charset="0"/>
+              <a:ea typeface="Cambria" panose="02040503050406030204" pitchFamily="18" charset="0"/>
+            </a:endParaRPr>
+          </a:p>
+        </p:txBody>
+      </p:sp>
+      <p:sp>
+        <p:nvSpPr>
+          <p:cNvPr id="35" name="!!11">
+            <a:extLst>
+              <a:ext uri="{FF2B5EF4-FFF2-40B4-BE49-F238E27FC236}">
+                <a16:creationId xmlns:a16="http://schemas.microsoft.com/office/drawing/2014/main" id="{C9BFDF2B-F0B1-37DD-8D06-801B3112C732}"/>
+              </a:ext>
+            </a:extLst>
+          </p:cNvPr>
+          <p:cNvSpPr/>
+          <p:nvPr/>
+        </p:nvSpPr>
+        <p:spPr>
+          <a:xfrm>
+            <a:off x="380138" y="1112834"/>
+            <a:ext cx="8383724" cy="974425"/>
+          </a:xfrm>
+          <a:prstGeom prst="roundRect">
+            <a:avLst>
+              <a:gd name="adj" fmla="val 8750"/>
+            </a:avLst>
+          </a:prstGeom>
+          <a:solidFill>
+            <a:srgbClr val="1E293B"/>
+          </a:solidFill>
+          <a:ln w="12700">
+            <a:solidFill>
+              <a:srgbClr val="64748B">
+                <a:alpha val="60000"/>
+              </a:srgbClr>
+            </a:solidFill>
+            <a:prstDash val="solid"/>
+          </a:ln>
+          <a:effectLst>
+            <a:outerShdw blurRad="152400" dist="38100" dir="2700000" algn="bl" rotWithShape="0">
+              <a:srgbClr val="000000">
+                <a:alpha val="18000"/>
+              </a:srgbClr>
+            </a:outerShdw>
+          </a:effectLst>
+        </p:spPr>
+        <p:txBody>
+          <a:bodyPr/>
+          <a:lstStyle/>
+          <a:p>
+            <a:endParaRPr lang="de-DE">
+              <a:latin typeface="Cambria" panose="02040503050406030204" pitchFamily="18" charset="0"/>
+              <a:ea typeface="Cambria" panose="02040503050406030204" pitchFamily="18" charset="0"/>
+            </a:endParaRPr>
+          </a:p>
+        </p:txBody>
+      </p:sp>
+      <p:sp>
+        <p:nvSpPr>
+          <p:cNvPr id="36" name="Text 7">
+            <a:extLst>
+              <a:ext uri="{FF2B5EF4-FFF2-40B4-BE49-F238E27FC236}">
+                <a16:creationId xmlns:a16="http://schemas.microsoft.com/office/drawing/2014/main" id="{31E1A0A1-B087-5D45-B453-6950FFE956C3}"/>
+              </a:ext>
+            </a:extLst>
+          </p:cNvPr>
+          <p:cNvSpPr/>
+          <p:nvPr/>
+        </p:nvSpPr>
+        <p:spPr>
+          <a:xfrm>
+            <a:off x="380138" y="1225439"/>
+            <a:ext cx="8383723" cy="365245"/>
+          </a:xfrm>
+          <a:prstGeom prst="rect">
+            <a:avLst/>
+          </a:prstGeom>
+          <a:noFill/>
+          <a:ln/>
+        </p:spPr>
+        <p:txBody>
+          <a:bodyPr wrap="square" lIns="0" tIns="0" rIns="0" bIns="0" rtlCol="0" anchor="ctr"/>
+          <a:lstStyle/>
+          <a:p>
+            <a:pPr algn="ctr"/>
+            <a:r>
+              <a:rPr lang="en-GB" sz="2000" b="1" dirty="0" err="1">
+                <a:solidFill>
+                  <a:srgbClr val="14B8A6"/>
+                </a:solidFill>
+                <a:latin typeface="Cambria" panose="02040503050406030204" pitchFamily="18" charset="0"/>
+                <a:ea typeface="Cambria" panose="02040503050406030204" pitchFamily="18" charset="0"/>
+              </a:rPr>
+              <a:t>Algorithmus</a:t>
+            </a:r>
+            <a:r>
+              <a:rPr lang="en-GB" sz="2000" b="1" dirty="0">
+                <a:solidFill>
+                  <a:srgbClr val="14B8A6"/>
+                </a:solidFill>
+                <a:latin typeface="Cambria" panose="02040503050406030204" pitchFamily="18" charset="0"/>
+                <a:ea typeface="Cambria" panose="02040503050406030204" pitchFamily="18" charset="0"/>
+              </a:rPr>
+              <a:t>: Q-Learning (Off-Policy TD Learning)</a:t>
+            </a:r>
+          </a:p>
+        </p:txBody>
+      </p:sp>
+      <p:sp>
+        <p:nvSpPr>
+          <p:cNvPr id="37" name="Text 8">
+            <a:extLst>
+              <a:ext uri="{FF2B5EF4-FFF2-40B4-BE49-F238E27FC236}">
+                <a16:creationId xmlns:a16="http://schemas.microsoft.com/office/drawing/2014/main" id="{B702398D-09FA-991C-766C-B81608669720}"/>
+              </a:ext>
+            </a:extLst>
+          </p:cNvPr>
+          <p:cNvSpPr/>
+          <p:nvPr/>
+        </p:nvSpPr>
+        <p:spPr>
+          <a:xfrm>
+            <a:off x="380139" y="1590685"/>
+            <a:ext cx="8383724" cy="502920"/>
+          </a:xfrm>
+          <a:prstGeom prst="rect">
+            <a:avLst/>
+          </a:prstGeom>
+          <a:noFill/>
+          <a:ln/>
+        </p:spPr>
+        <p:txBody>
+          <a:bodyPr wrap="square" lIns="0" tIns="0" rIns="0" bIns="0" rtlCol="0" anchor="ctr"/>
+          <a:lstStyle/>
+          <a:p>
+            <a:pPr marL="0" indent="0" algn="ctr">
+              <a:buNone/>
+            </a:pPr>
+            <a:r>
+              <a:rPr lang="de-DE" sz="1400" b="1" dirty="0">
+                <a:solidFill>
+                  <a:srgbClr val="FFFFFF"/>
+                </a:solidFill>
+                <a:latin typeface="Cambria" panose="02040503050406030204" pitchFamily="18" charset="0"/>
+                <a:ea typeface="Cambria" panose="02040503050406030204" pitchFamily="18" charset="0"/>
+                <a:cs typeface="Courier New" pitchFamily="34" charset="-120"/>
+              </a:rPr>
+              <a:t>Bewährt für diskrete Action Spaces · Interpretierbar · Kein </a:t>
+            </a:r>
+            <a:r>
+              <a:rPr lang="de-DE" sz="1400" b="1" dirty="0" err="1">
+                <a:solidFill>
+                  <a:srgbClr val="FFFFFF"/>
+                </a:solidFill>
+                <a:latin typeface="Cambria" panose="02040503050406030204" pitchFamily="18" charset="0"/>
+                <a:ea typeface="Cambria" panose="02040503050406030204" pitchFamily="18" charset="0"/>
+                <a:cs typeface="Courier New" pitchFamily="34" charset="-120"/>
+              </a:rPr>
+              <a:t>Neural</a:t>
+            </a:r>
+            <a:r>
+              <a:rPr lang="de-DE" sz="1400" b="1" dirty="0">
+                <a:solidFill>
+                  <a:srgbClr val="FFFFFF"/>
+                </a:solidFill>
+                <a:latin typeface="Cambria" panose="02040503050406030204" pitchFamily="18" charset="0"/>
+                <a:ea typeface="Cambria" panose="02040503050406030204" pitchFamily="18" charset="0"/>
+                <a:cs typeface="Courier New" pitchFamily="34" charset="-120"/>
+              </a:rPr>
+              <a:t> Network erforderlich</a:t>
+            </a:r>
+          </a:p>
+        </p:txBody>
+      </p:sp>
+      <p:sp>
+        <p:nvSpPr>
+          <p:cNvPr id="44" name="!!11">
+            <a:extLst>
+              <a:ext uri="{FF2B5EF4-FFF2-40B4-BE49-F238E27FC236}">
+                <a16:creationId xmlns:a16="http://schemas.microsoft.com/office/drawing/2014/main" id="{ED5BFF46-C423-7850-A649-C3C16EE46426}"/>
+              </a:ext>
+            </a:extLst>
+          </p:cNvPr>
+          <p:cNvSpPr/>
+          <p:nvPr/>
+        </p:nvSpPr>
+        <p:spPr>
+          <a:xfrm>
+            <a:off x="2319826" y="3652432"/>
+            <a:ext cx="1735979" cy="1216748"/>
+          </a:xfrm>
+          <a:prstGeom prst="roundRect">
+            <a:avLst>
+              <a:gd name="adj" fmla="val 8750"/>
+            </a:avLst>
+          </a:prstGeom>
+          <a:solidFill>
+            <a:srgbClr val="F1F5F9"/>
+          </a:solidFill>
+          <a:ln w="12700">
+            <a:solidFill>
+              <a:srgbClr val="0D9488">
+                <a:alpha val="40000"/>
+              </a:srgbClr>
+            </a:solidFill>
+            <a:prstDash val="solid"/>
+          </a:ln>
+          <a:effectLst>
+            <a:outerShdw blurRad="101600" dist="25400" dir="2700000" algn="bl" rotWithShape="0">
+              <a:srgbClr val="000000">
+                <a:alpha val="14000"/>
+              </a:srgbClr>
+            </a:outerShdw>
+          </a:effectLst>
+        </p:spPr>
+        <p:txBody>
+          <a:bodyPr/>
+          <a:lstStyle/>
+          <a:p>
+            <a:endParaRPr lang="de-DE">
+              <a:latin typeface="Cambria" panose="02040503050406030204" pitchFamily="18" charset="0"/>
+              <a:ea typeface="Cambria" panose="02040503050406030204" pitchFamily="18" charset="0"/>
+            </a:endParaRPr>
+          </a:p>
+        </p:txBody>
+      </p:sp>
+      <p:sp>
+        <p:nvSpPr>
+          <p:cNvPr id="45" name="Text 10">
+            <a:extLst>
+              <a:ext uri="{FF2B5EF4-FFF2-40B4-BE49-F238E27FC236}">
+                <a16:creationId xmlns:a16="http://schemas.microsoft.com/office/drawing/2014/main" id="{72C6A2B9-0343-66AF-4E24-7BA9B8CB346F}"/>
+              </a:ext>
+            </a:extLst>
+          </p:cNvPr>
+          <p:cNvSpPr/>
+          <p:nvPr/>
+        </p:nvSpPr>
+        <p:spPr>
+          <a:xfrm>
+            <a:off x="2319826" y="3722719"/>
+            <a:ext cx="1735979" cy="342210"/>
+          </a:xfrm>
+          <a:prstGeom prst="rect">
+            <a:avLst/>
+          </a:prstGeom>
+          <a:noFill/>
+          <a:ln/>
+        </p:spPr>
+        <p:txBody>
+          <a:bodyPr wrap="square" lIns="0" tIns="0" rIns="0" bIns="0" rtlCol="0" anchor="ctr"/>
+          <a:lstStyle/>
+          <a:p>
+            <a:pPr marL="0" indent="0" algn="ctr">
+              <a:buNone/>
+            </a:pPr>
+            <a:r>
+              <a:rPr lang="el-GR" sz="2400" b="1" dirty="0">
+                <a:solidFill>
+                  <a:srgbClr val="14B8A6"/>
+                </a:solidFill>
+                <a:latin typeface="Cambria" panose="02040503050406030204" pitchFamily="18" charset="0"/>
+                <a:ea typeface="Cambria" panose="02040503050406030204" pitchFamily="18" charset="0"/>
+                <a:cs typeface="Cambria" pitchFamily="34" charset="-120"/>
+              </a:rPr>
+              <a:t>γ</a:t>
+            </a:r>
+            <a:endParaRPr lang="en-US" sz="2400" dirty="0">
+              <a:latin typeface="Cambria" panose="02040503050406030204" pitchFamily="18" charset="0"/>
+              <a:ea typeface="Cambria" panose="02040503050406030204" pitchFamily="18" charset="0"/>
+            </a:endParaRPr>
+          </a:p>
+        </p:txBody>
+      </p:sp>
+      <p:sp>
+        <p:nvSpPr>
+          <p:cNvPr id="46" name="Text 11">
+            <a:extLst>
+              <a:ext uri="{FF2B5EF4-FFF2-40B4-BE49-F238E27FC236}">
+                <a16:creationId xmlns:a16="http://schemas.microsoft.com/office/drawing/2014/main" id="{C63F1E1B-957F-1F09-5289-D7A356708F09}"/>
+              </a:ext>
+            </a:extLst>
+          </p:cNvPr>
+          <p:cNvSpPr/>
+          <p:nvPr/>
+        </p:nvSpPr>
+        <p:spPr>
+          <a:xfrm>
+            <a:off x="2319826" y="4071612"/>
+            <a:ext cx="1735979" cy="228140"/>
+          </a:xfrm>
+          <a:prstGeom prst="rect">
+            <a:avLst/>
+          </a:prstGeom>
+          <a:noFill/>
+          <a:ln/>
+        </p:spPr>
+        <p:txBody>
+          <a:bodyPr wrap="square" lIns="0" tIns="0" rIns="0" bIns="0" rtlCol="0" anchor="ctr"/>
+          <a:lstStyle/>
+          <a:p>
+            <a:pPr algn="ctr"/>
+            <a:r>
+              <a:rPr lang="en-US" sz="1200" b="1" dirty="0">
+                <a:solidFill>
+                  <a:srgbClr val="F59E0B"/>
+                </a:solidFill>
+                <a:latin typeface="Cambria" panose="02040503050406030204" pitchFamily="18" charset="0"/>
+                <a:ea typeface="Cambria" panose="02040503050406030204" pitchFamily="18" charset="0"/>
+              </a:rPr>
+              <a:t>0.99</a:t>
+            </a:r>
+            <a:endParaRPr lang="en-US" sz="1200" dirty="0">
+              <a:latin typeface="Cambria" panose="02040503050406030204" pitchFamily="18" charset="0"/>
+              <a:ea typeface="Cambria" panose="02040503050406030204" pitchFamily="18" charset="0"/>
+            </a:endParaRPr>
+          </a:p>
+        </p:txBody>
+      </p:sp>
+      <p:sp>
+        <p:nvSpPr>
+          <p:cNvPr id="47" name="Text 12">
+            <a:extLst>
+              <a:ext uri="{FF2B5EF4-FFF2-40B4-BE49-F238E27FC236}">
+                <a16:creationId xmlns:a16="http://schemas.microsoft.com/office/drawing/2014/main" id="{EA609EA1-BB05-07FD-53C7-883F03BB4757}"/>
+              </a:ext>
+            </a:extLst>
+          </p:cNvPr>
+          <p:cNvSpPr/>
+          <p:nvPr/>
+        </p:nvSpPr>
+        <p:spPr>
+          <a:xfrm>
+            <a:off x="2319826" y="4322566"/>
+            <a:ext cx="1735979" cy="167303"/>
+          </a:xfrm>
+          <a:prstGeom prst="rect">
+            <a:avLst/>
+          </a:prstGeom>
+          <a:noFill/>
+        </p:spPr>
+        <p:txBody>
+          <a:bodyPr wrap="square" lIns="0" tIns="0" rIns="0" bIns="0" anchor="ctr"/>
+          <a:lstStyle/>
+          <a:p>
+            <a:pPr algn="ctr"/>
+            <a:r>
+              <a:rPr lang="en-US" sz="1100" b="1" dirty="0">
+                <a:solidFill>
+                  <a:srgbClr val="1E293B"/>
+                </a:solidFill>
+                <a:latin typeface="Cambria" panose="02040503050406030204" pitchFamily="18" charset="0"/>
+                <a:ea typeface="Cambria" panose="02040503050406030204" pitchFamily="18" charset="0"/>
+              </a:rPr>
+              <a:t>Discount Factor</a:t>
+            </a:r>
+          </a:p>
+        </p:txBody>
+      </p:sp>
+      <p:sp>
+        <p:nvSpPr>
+          <p:cNvPr id="48" name="Text 13">
+            <a:extLst>
+              <a:ext uri="{FF2B5EF4-FFF2-40B4-BE49-F238E27FC236}">
+                <a16:creationId xmlns:a16="http://schemas.microsoft.com/office/drawing/2014/main" id="{E705EB27-B13C-E57B-4CA2-23B3B039BEE6}"/>
+              </a:ext>
+            </a:extLst>
+          </p:cNvPr>
+          <p:cNvSpPr/>
+          <p:nvPr/>
+        </p:nvSpPr>
+        <p:spPr>
+          <a:xfrm>
+            <a:off x="2319826" y="4519365"/>
+            <a:ext cx="1735979" cy="197722"/>
+          </a:xfrm>
+          <a:prstGeom prst="rect">
+            <a:avLst/>
+          </a:prstGeom>
+          <a:noFill/>
+          <a:ln/>
+        </p:spPr>
+        <p:txBody>
+          <a:bodyPr wrap="square" lIns="0" tIns="0" rIns="0" bIns="0" rtlCol="0" anchor="ctr"/>
+          <a:lstStyle/>
+          <a:p>
+            <a:pPr marL="0" indent="0" algn="ctr">
+              <a:buNone/>
+            </a:pPr>
+            <a:r>
+              <a:rPr lang="en-US" sz="850" dirty="0" err="1">
+                <a:solidFill>
+                  <a:srgbClr val="94A3B8"/>
+                </a:solidFill>
+                <a:latin typeface="Cambria" panose="02040503050406030204" pitchFamily="18" charset="0"/>
+                <a:ea typeface="Cambria" panose="02040503050406030204" pitchFamily="18" charset="0"/>
+              </a:rPr>
+              <a:t>Gewichtung</a:t>
+            </a:r>
+            <a:r>
+              <a:rPr lang="en-US" sz="850" dirty="0">
+                <a:solidFill>
+                  <a:srgbClr val="94A3B8"/>
+                </a:solidFill>
+                <a:latin typeface="Cambria" panose="02040503050406030204" pitchFamily="18" charset="0"/>
+                <a:ea typeface="Cambria" panose="02040503050406030204" pitchFamily="18" charset="0"/>
+              </a:rPr>
+              <a:t> </a:t>
+            </a:r>
+            <a:r>
+              <a:rPr lang="en-US" sz="850" dirty="0" err="1">
+                <a:solidFill>
+                  <a:srgbClr val="94A3B8"/>
+                </a:solidFill>
+                <a:latin typeface="Cambria" panose="02040503050406030204" pitchFamily="18" charset="0"/>
+                <a:ea typeface="Cambria" panose="02040503050406030204" pitchFamily="18" charset="0"/>
+              </a:rPr>
+              <a:t>zukünftiger</a:t>
+            </a:r>
+            <a:r>
+              <a:rPr lang="en-US" sz="850" dirty="0">
+                <a:solidFill>
+                  <a:srgbClr val="94A3B8"/>
+                </a:solidFill>
+                <a:latin typeface="Cambria" panose="02040503050406030204" pitchFamily="18" charset="0"/>
+                <a:ea typeface="Cambria" panose="02040503050406030204" pitchFamily="18" charset="0"/>
+              </a:rPr>
+              <a:t> Rewards</a:t>
+            </a:r>
+          </a:p>
+        </p:txBody>
+      </p:sp>
+      <p:sp>
+        <p:nvSpPr>
+          <p:cNvPr id="57" name="Text 16">
+            <a:extLst>
+              <a:ext uri="{FF2B5EF4-FFF2-40B4-BE49-F238E27FC236}">
+                <a16:creationId xmlns:a16="http://schemas.microsoft.com/office/drawing/2014/main" id="{B4BC0E0F-1A87-3D1E-416E-F3333560B39A}"/>
+              </a:ext>
+            </a:extLst>
+          </p:cNvPr>
+          <p:cNvSpPr/>
+          <p:nvPr/>
+        </p:nvSpPr>
+        <p:spPr>
+          <a:xfrm>
+            <a:off x="4217389" y="4071612"/>
+            <a:ext cx="1539367" cy="228140"/>
+          </a:xfrm>
+          <a:prstGeom prst="rect">
+            <a:avLst/>
+          </a:prstGeom>
+          <a:noFill/>
+          <a:ln/>
+        </p:spPr>
+        <p:txBody>
+          <a:bodyPr wrap="square" lIns="0" tIns="0" rIns="0" bIns="0" rtlCol="0" anchor="ctr"/>
+          <a:lstStyle/>
+          <a:p>
+            <a:pPr marL="0" indent="0" algn="ctr">
+              <a:buNone/>
+            </a:pPr>
+            <a:r>
+              <a:rPr lang="en-US" sz="1200" b="1" dirty="0">
+                <a:solidFill>
+                  <a:srgbClr val="F59E0B"/>
+                </a:solidFill>
+                <a:latin typeface="Cambria" panose="02040503050406030204" pitchFamily="18" charset="0"/>
+                <a:ea typeface="Cambria" panose="02040503050406030204" pitchFamily="18" charset="0"/>
+              </a:rPr>
+              <a:t>1.0</a:t>
+            </a:r>
+            <a:endParaRPr lang="en-US" sz="1200" dirty="0">
+              <a:latin typeface="Cambria" panose="02040503050406030204" pitchFamily="18" charset="0"/>
+              <a:ea typeface="Cambria" panose="02040503050406030204" pitchFamily="18" charset="0"/>
+            </a:endParaRPr>
+          </a:p>
+        </p:txBody>
+      </p:sp>
+      <p:sp>
+        <p:nvSpPr>
+          <p:cNvPr id="58" name="Text 17">
+            <a:extLst>
+              <a:ext uri="{FF2B5EF4-FFF2-40B4-BE49-F238E27FC236}">
+                <a16:creationId xmlns:a16="http://schemas.microsoft.com/office/drawing/2014/main" id="{851CC3BD-78CA-4C3A-6B19-CEFE034D15A4}"/>
+              </a:ext>
+            </a:extLst>
+          </p:cNvPr>
+          <p:cNvSpPr/>
+          <p:nvPr/>
+        </p:nvSpPr>
+        <p:spPr>
+          <a:xfrm>
+            <a:off x="4217389" y="4322566"/>
+            <a:ext cx="1539367" cy="167303"/>
+          </a:xfrm>
+          <a:prstGeom prst="rect">
+            <a:avLst/>
+          </a:prstGeom>
+          <a:noFill/>
+        </p:spPr>
+        <p:txBody>
+          <a:bodyPr wrap="square" lIns="0" tIns="0" rIns="0" bIns="0" anchor="ctr"/>
+          <a:lstStyle/>
+          <a:p>
+            <a:pPr algn="ctr"/>
+            <a:r>
+              <a:rPr lang="en-US" sz="1100" b="1" dirty="0">
+                <a:solidFill>
+                  <a:srgbClr val="1E293B"/>
+                </a:solidFill>
+                <a:latin typeface="Cambria" panose="02040503050406030204" pitchFamily="18" charset="0"/>
+                <a:ea typeface="Cambria" panose="02040503050406030204" pitchFamily="18" charset="0"/>
+              </a:rPr>
+              <a:t>Initial</a:t>
+            </a:r>
+          </a:p>
+        </p:txBody>
+      </p:sp>
+      <p:sp>
+        <p:nvSpPr>
+          <p:cNvPr id="59" name="Text 18">
+            <a:extLst>
+              <a:ext uri="{FF2B5EF4-FFF2-40B4-BE49-F238E27FC236}">
+                <a16:creationId xmlns:a16="http://schemas.microsoft.com/office/drawing/2014/main" id="{A51134CE-4C7A-27DC-8259-D74EBDAD306D}"/>
+              </a:ext>
+            </a:extLst>
+          </p:cNvPr>
+          <p:cNvSpPr/>
+          <p:nvPr/>
+        </p:nvSpPr>
+        <p:spPr>
+          <a:xfrm>
+            <a:off x="4217389" y="4519365"/>
+            <a:ext cx="1539367" cy="197722"/>
+          </a:xfrm>
+          <a:prstGeom prst="rect">
+            <a:avLst/>
+          </a:prstGeom>
+          <a:noFill/>
+          <a:ln/>
+        </p:spPr>
+        <p:txBody>
+          <a:bodyPr wrap="square" lIns="0" tIns="0" rIns="0" bIns="0" rtlCol="0" anchor="ctr"/>
+          <a:lstStyle/>
+          <a:p>
+            <a:pPr marL="0" indent="0" algn="ctr">
+              <a:buNone/>
+            </a:pPr>
+            <a:r>
+              <a:rPr lang="en-US" sz="850" dirty="0" err="1">
+                <a:solidFill>
+                  <a:srgbClr val="94A3B8"/>
+                </a:solidFill>
+                <a:latin typeface="Cambria" panose="02040503050406030204" pitchFamily="18" charset="0"/>
+                <a:ea typeface="Cambria" panose="02040503050406030204" pitchFamily="18" charset="0"/>
+              </a:rPr>
+              <a:t>Vollständige</a:t>
+            </a:r>
+            <a:r>
+              <a:rPr lang="en-US" sz="850" dirty="0">
+                <a:solidFill>
+                  <a:srgbClr val="94A3B8"/>
+                </a:solidFill>
+                <a:latin typeface="Cambria" panose="02040503050406030204" pitchFamily="18" charset="0"/>
+                <a:ea typeface="Cambria" panose="02040503050406030204" pitchFamily="18" charset="0"/>
+              </a:rPr>
+              <a:t> Exploration </a:t>
+            </a:r>
+            <a:r>
+              <a:rPr lang="en-US" sz="850" dirty="0" err="1">
+                <a:solidFill>
+                  <a:srgbClr val="94A3B8"/>
+                </a:solidFill>
+                <a:latin typeface="Cambria" panose="02040503050406030204" pitchFamily="18" charset="0"/>
+                <a:ea typeface="Cambria" panose="02040503050406030204" pitchFamily="18" charset="0"/>
+              </a:rPr>
+              <a:t>zu</a:t>
+            </a:r>
+            <a:r>
+              <a:rPr lang="en-US" sz="850" dirty="0">
+                <a:solidFill>
+                  <a:srgbClr val="94A3B8"/>
+                </a:solidFill>
+                <a:latin typeface="Cambria" panose="02040503050406030204" pitchFamily="18" charset="0"/>
+                <a:ea typeface="Cambria" panose="02040503050406030204" pitchFamily="18" charset="0"/>
+              </a:rPr>
+              <a:t> </a:t>
+            </a:r>
+            <a:r>
+              <a:rPr lang="en-US" sz="850" dirty="0" err="1">
+                <a:solidFill>
+                  <a:srgbClr val="94A3B8"/>
+                </a:solidFill>
+                <a:latin typeface="Cambria" panose="02040503050406030204" pitchFamily="18" charset="0"/>
+                <a:ea typeface="Cambria" panose="02040503050406030204" pitchFamily="18" charset="0"/>
+              </a:rPr>
+              <a:t>Beginn</a:t>
+            </a:r>
+            <a:endParaRPr lang="en-US" sz="850" dirty="0">
+              <a:solidFill>
+                <a:srgbClr val="94A3B8"/>
+              </a:solidFill>
+              <a:latin typeface="Cambria" panose="02040503050406030204" pitchFamily="18" charset="0"/>
+              <a:ea typeface="Cambria" panose="02040503050406030204" pitchFamily="18" charset="0"/>
+            </a:endParaRPr>
+          </a:p>
+        </p:txBody>
+      </p:sp>
+      <p:sp>
+        <p:nvSpPr>
+          <p:cNvPr id="60" name="Text 16">
+            <a:extLst>
+              <a:ext uri="{FF2B5EF4-FFF2-40B4-BE49-F238E27FC236}">
+                <a16:creationId xmlns:a16="http://schemas.microsoft.com/office/drawing/2014/main" id="{DB04C67A-4018-7249-1459-117D55251D93}"/>
+              </a:ext>
+            </a:extLst>
+          </p:cNvPr>
+          <p:cNvSpPr/>
+          <p:nvPr/>
+        </p:nvSpPr>
+        <p:spPr>
+          <a:xfrm>
+            <a:off x="7215008" y="4071612"/>
+            <a:ext cx="1539367" cy="228140"/>
+          </a:xfrm>
+          <a:prstGeom prst="rect">
+            <a:avLst/>
+          </a:prstGeom>
+          <a:noFill/>
+          <a:ln/>
+        </p:spPr>
+        <p:txBody>
+          <a:bodyPr wrap="square" lIns="0" tIns="0" rIns="0" bIns="0" rtlCol="0" anchor="ctr"/>
+          <a:lstStyle/>
+          <a:p>
+            <a:pPr marL="0" indent="0" algn="ctr">
+              <a:buNone/>
+            </a:pPr>
+            <a:r>
+              <a:rPr lang="en-US" sz="1200" b="1" dirty="0">
+                <a:solidFill>
+                  <a:srgbClr val="F59E0B"/>
+                </a:solidFill>
+                <a:latin typeface="Cambria" panose="02040503050406030204" pitchFamily="18" charset="0"/>
+                <a:ea typeface="Cambria" panose="02040503050406030204" pitchFamily="18" charset="0"/>
+              </a:rPr>
+              <a:t>0.10</a:t>
+            </a:r>
+          </a:p>
+        </p:txBody>
+      </p:sp>
+      <p:sp>
+        <p:nvSpPr>
+          <p:cNvPr id="61" name="Text 17">
+            <a:extLst>
+              <a:ext uri="{FF2B5EF4-FFF2-40B4-BE49-F238E27FC236}">
+                <a16:creationId xmlns:a16="http://schemas.microsoft.com/office/drawing/2014/main" id="{005A937C-2727-8039-7102-BCD7D09B3B81}"/>
+              </a:ext>
+            </a:extLst>
+          </p:cNvPr>
+          <p:cNvSpPr/>
+          <p:nvPr/>
+        </p:nvSpPr>
+        <p:spPr>
+          <a:xfrm>
+            <a:off x="7215008" y="4322566"/>
+            <a:ext cx="1539367" cy="167303"/>
+          </a:xfrm>
+          <a:prstGeom prst="rect">
+            <a:avLst/>
+          </a:prstGeom>
+          <a:noFill/>
+        </p:spPr>
+        <p:txBody>
+          <a:bodyPr wrap="square" lIns="0" tIns="0" rIns="0" bIns="0" anchor="ctr"/>
+          <a:lstStyle/>
+          <a:p>
+            <a:pPr algn="ctr"/>
+            <a:r>
+              <a:rPr lang="en-US" sz="1100" b="1" dirty="0">
+                <a:solidFill>
+                  <a:srgbClr val="1E293B"/>
+                </a:solidFill>
+                <a:latin typeface="Cambria" panose="02040503050406030204" pitchFamily="18" charset="0"/>
+                <a:ea typeface="Cambria" panose="02040503050406030204" pitchFamily="18" charset="0"/>
+              </a:rPr>
+              <a:t>Final</a:t>
+            </a:r>
+          </a:p>
+        </p:txBody>
+      </p:sp>
+      <p:sp>
+        <p:nvSpPr>
+          <p:cNvPr id="62" name="Text 18">
+            <a:extLst>
+              <a:ext uri="{FF2B5EF4-FFF2-40B4-BE49-F238E27FC236}">
+                <a16:creationId xmlns:a16="http://schemas.microsoft.com/office/drawing/2014/main" id="{09D50986-EBDF-21A3-D6BE-D4ABA8E65B10}"/>
+              </a:ext>
+            </a:extLst>
+          </p:cNvPr>
+          <p:cNvSpPr/>
+          <p:nvPr/>
+        </p:nvSpPr>
+        <p:spPr>
+          <a:xfrm>
+            <a:off x="7285703" y="4519365"/>
+            <a:ext cx="1397978" cy="197722"/>
+          </a:xfrm>
+          <a:prstGeom prst="rect">
+            <a:avLst/>
+          </a:prstGeom>
+          <a:noFill/>
+          <a:ln/>
+        </p:spPr>
+        <p:txBody>
+          <a:bodyPr wrap="square" lIns="0" tIns="0" rIns="0" bIns="0" rtlCol="0" anchor="ctr"/>
+          <a:lstStyle/>
+          <a:p>
+            <a:pPr marL="0" indent="0" algn="ctr">
+              <a:buNone/>
+            </a:pPr>
+            <a:r>
+              <a:rPr lang="en-US" sz="850" dirty="0" err="1">
+                <a:solidFill>
+                  <a:srgbClr val="94A3B8"/>
+                </a:solidFill>
+                <a:latin typeface="Cambria" panose="02040503050406030204" pitchFamily="18" charset="0"/>
+                <a:ea typeface="Cambria" panose="02040503050406030204" pitchFamily="18" charset="0"/>
+              </a:rPr>
+              <a:t>Residuale</a:t>
+            </a:r>
+            <a:r>
+              <a:rPr lang="en-US" sz="850" dirty="0">
+                <a:solidFill>
+                  <a:srgbClr val="94A3B8"/>
+                </a:solidFill>
+                <a:latin typeface="Cambria" panose="02040503050406030204" pitchFamily="18" charset="0"/>
+                <a:ea typeface="Cambria" panose="02040503050406030204" pitchFamily="18" charset="0"/>
+              </a:rPr>
+              <a:t> Exploration am Ende</a:t>
+            </a:r>
+          </a:p>
+        </p:txBody>
+      </p:sp>
     </p:spTree>
     <p:extLst>
       <p:ext uri="{BB962C8B-B14F-4D97-AF65-F5344CB8AC3E}">
@@ -7106,7 +8777,7 @@
     </p:extLst>
   </p:cSld>
   <p:clrMapOvr>
-    <a:masterClrMapping/>
+    <a:overrideClrMapping bg1="lt1" tx1="dk1" bg2="lt2" tx2="dk2" accent1="accent1" accent2="accent2" accent3="accent3" accent4="accent4" accent5="accent5" accent6="accent6" hlink="hlink" folHlink="folHlink"/>
   </p:clrMapOvr>
   <mc:AlternateContent xmlns:mc="http://schemas.openxmlformats.org/markup-compatibility/2006" xmlns:p14="http://schemas.microsoft.com/office/powerpoint/2010/main">
     <mc:Choice Requires="p14">
@@ -14115,7 +15786,7 @@
         </p:nvSpPr>
         <p:spPr>
           <a:xfrm>
-            <a:off x="530352" y="1188720"/>
+            <a:off x="530352" y="1277209"/>
             <a:ext cx="3657600" cy="201168"/>
           </a:xfrm>
           <a:prstGeom prst="rect">
@@ -14163,7 +15834,7 @@
         </p:nvSpPr>
         <p:spPr>
           <a:xfrm>
-            <a:off x="530352" y="1550642"/>
+            <a:off x="530352" y="1639131"/>
             <a:ext cx="3657600" cy="1035176"/>
           </a:xfrm>
           <a:prstGeom prst="rect">
@@ -14254,7 +15925,7 @@
         </p:nvSpPr>
         <p:spPr>
           <a:xfrm>
-            <a:off x="4782312" y="1188720"/>
+            <a:off x="4782312" y="1277209"/>
             <a:ext cx="3657600" cy="201168"/>
           </a:xfrm>
           <a:prstGeom prst="rect">
@@ -14302,7 +15973,7 @@
         </p:nvSpPr>
         <p:spPr>
           <a:xfrm>
-            <a:off x="4782312" y="1550642"/>
+            <a:off x="4782312" y="1639131"/>
             <a:ext cx="3657600" cy="1035176"/>
           </a:xfrm>
           <a:prstGeom prst="rect">
@@ -14382,7 +16053,7 @@
         </p:nvSpPr>
         <p:spPr>
           <a:xfrm>
-            <a:off x="4782312" y="2452633"/>
+            <a:off x="4782312" y="2541122"/>
             <a:ext cx="3657600" cy="274320"/>
           </a:xfrm>
           <a:prstGeom prst="rect">
@@ -14429,7 +16100,7 @@
         </p:nvSpPr>
         <p:spPr>
           <a:xfrm>
-            <a:off x="530352" y="2452633"/>
+            <a:off x="530352" y="2541122"/>
             <a:ext cx="3657600" cy="274320"/>
           </a:xfrm>
           <a:prstGeom prst="rect">
@@ -19677,13 +21348,13 @@
   <p:clrMapOvr>
     <a:masterClrMapping/>
   </p:clrMapOvr>
-  <mc:AlternateContent xmlns:mc="http://schemas.openxmlformats.org/markup-compatibility/2006">
-    <mc:Choice xmlns:p159="http://schemas.microsoft.com/office/powerpoint/2015/09/main" Requires="p159">
+  <mc:AlternateContent xmlns:mc="http://schemas.openxmlformats.org/markup-compatibility/2006" xmlns:p159="http://schemas.microsoft.com/office/powerpoint/2015/09/main">
+    <mc:Choice Requires="p159">
       <p:transition xmlns:p14="http://schemas.microsoft.com/office/powerpoint/2010/main" spd="slow" p14:dur="2000">
         <p159:morph option="byObject"/>
       </p:transition>
     </mc:Choice>
-    <mc:Fallback>
+    <mc:Fallback xmlns="">
       <p:transition spd="slow">
         <p:fade/>
       </p:transition>
@@ -21000,13 +22671,13 @@
   <p:clrMapOvr>
     <a:masterClrMapping/>
   </p:clrMapOvr>
-  <mc:AlternateContent xmlns:mc="http://schemas.openxmlformats.org/markup-compatibility/2006">
-    <mc:Choice xmlns:p159="http://schemas.microsoft.com/office/powerpoint/2015/09/main" Requires="p159">
+  <mc:AlternateContent xmlns:mc="http://schemas.openxmlformats.org/markup-compatibility/2006" xmlns:p159="http://schemas.microsoft.com/office/powerpoint/2015/09/main">
+    <mc:Choice Requires="p159">
       <p:transition xmlns:p14="http://schemas.microsoft.com/office/powerpoint/2010/main" spd="slow" p14:dur="2000">
         <p159:morph option="byObject"/>
       </p:transition>
     </mc:Choice>
-    <mc:Fallback>
+    <mc:Fallback xmlns="">
       <p:transition spd="slow">
         <p:fade/>
       </p:transition>
@@ -22323,13 +23994,13 @@
   <p:clrMapOvr>
     <a:masterClrMapping/>
   </p:clrMapOvr>
-  <mc:AlternateContent xmlns:mc="http://schemas.openxmlformats.org/markup-compatibility/2006">
-    <mc:Choice xmlns:p159="http://schemas.microsoft.com/office/powerpoint/2015/09/main" Requires="p159">
+  <mc:AlternateContent xmlns:mc="http://schemas.openxmlformats.org/markup-compatibility/2006" xmlns:p159="http://schemas.microsoft.com/office/powerpoint/2015/09/main">
+    <mc:Choice Requires="p159">
       <p:transition xmlns:p14="http://schemas.microsoft.com/office/powerpoint/2010/main" spd="slow" p14:dur="2000">
         <p159:morph option="byObject"/>
       </p:transition>
     </mc:Choice>
-    <mc:Fallback>
+    <mc:Fallback xmlns="">
       <p:transition spd="slow">
         <p:fade/>
       </p:transition>
@@ -23089,4 +24760,90 @@
     </a:ext>
   </a:extLst>
 </a:theme>
+</file>
+
+<file path=ppt/theme/themeOverride1.xml><?xml version="1.0" encoding="utf-8"?>
+<a:themeOverride xmlns:a="http://schemas.openxmlformats.org/drawingml/2006/main">
+  <a:clrScheme name="Office">
+    <a:dk1>
+      <a:sysClr val="windowText" lastClr="000000"/>
+    </a:dk1>
+    <a:lt1>
+      <a:sysClr val="window" lastClr="FFFFFF"/>
+    </a:lt1>
+    <a:dk2>
+      <a:srgbClr val="44546A"/>
+    </a:dk2>
+    <a:lt2>
+      <a:srgbClr val="E7E6E6"/>
+    </a:lt2>
+    <a:accent1>
+      <a:srgbClr val="4472C4"/>
+    </a:accent1>
+    <a:accent2>
+      <a:srgbClr val="ED7D31"/>
+    </a:accent2>
+    <a:accent3>
+      <a:srgbClr val="A5A5A5"/>
+    </a:accent3>
+    <a:accent4>
+      <a:srgbClr val="FFC000"/>
+    </a:accent4>
+    <a:accent5>
+      <a:srgbClr val="5B9BD5"/>
+    </a:accent5>
+    <a:accent6>
+      <a:srgbClr val="70AD47"/>
+    </a:accent6>
+    <a:hlink>
+      <a:srgbClr val="0563C1"/>
+    </a:hlink>
+    <a:folHlink>
+      <a:srgbClr val="954F72"/>
+    </a:folHlink>
+  </a:clrScheme>
+</a:themeOverride>
+</file>
+
+<file path=ppt/theme/themeOverride2.xml><?xml version="1.0" encoding="utf-8"?>
+<a:themeOverride xmlns:a="http://schemas.openxmlformats.org/drawingml/2006/main">
+  <a:clrScheme name="Office">
+    <a:dk1>
+      <a:sysClr val="windowText" lastClr="000000"/>
+    </a:dk1>
+    <a:lt1>
+      <a:sysClr val="window" lastClr="FFFFFF"/>
+    </a:lt1>
+    <a:dk2>
+      <a:srgbClr val="44546A"/>
+    </a:dk2>
+    <a:lt2>
+      <a:srgbClr val="E7E6E6"/>
+    </a:lt2>
+    <a:accent1>
+      <a:srgbClr val="4472C4"/>
+    </a:accent1>
+    <a:accent2>
+      <a:srgbClr val="ED7D31"/>
+    </a:accent2>
+    <a:accent3>
+      <a:srgbClr val="A5A5A5"/>
+    </a:accent3>
+    <a:accent4>
+      <a:srgbClr val="FFC000"/>
+    </a:accent4>
+    <a:accent5>
+      <a:srgbClr val="5B9BD5"/>
+    </a:accent5>
+    <a:accent6>
+      <a:srgbClr val="70AD47"/>
+    </a:accent6>
+    <a:hlink>
+      <a:srgbClr val="0563C1"/>
+    </a:hlink>
+    <a:folHlink>
+      <a:srgbClr val="954F72"/>
+    </a:folHlink>
+  </a:clrScheme>
+</a:themeOverride>
 </file>
</xml_diff>